<commit_message>
Add complete synchronized capstone deliverables and PDFs
</commit_message>
<xml_diff>
--- a/public/presentations/autobiography-presentation.pptx
+++ b/public/presentations/autobiography-presentation.pptx
@@ -12,8 +12,10 @@
     <p:sldId id="259" r:id="rId7"/>
     <p:sldId id="260" r:id="rId8"/>
     <p:sldId id="261" r:id="rId9"/>
+    <p:sldId id="262" r:id="rId10"/>
+    <p:sldId id="263" r:id="rId11"/>
   </p:sldIdLst>
-  <p:sldSz cx="9144000" cy="6858000"/>
+  <p:sldSz cx="12192000" cy="6858000"/>
   <p:notesSz cx="7772400" cy="10058400"/>
 </p:presentation>
 </file>
@@ -308,7 +310,7 @@
               </a:lnSpc>
               <a:buNone/>
             </a:pPr>
-            <a:fld id="{14A3F099-311C-4805-95C4-9E95C539DB2B}" type="slidenum">
+            <a:fld id="{102FD909-A640-494D-BEF1-348A66D89FA7}" type="slidenum">
               <a:rPr lang="en-US" sz="1200" b="0" u="none" strike="noStrike">
                 <a:solidFill>
                   <a:schemeClr val="dk1">
@@ -344,8 +346,8 @@
         </p:nvSpPr>
         <p:spPr>
           <a:xfrm>
-            <a:off x="457200" y="1604520"/>
-            <a:ext cx="8229240" cy="3977280"/>
+            <a:off x="609480" y="1604520"/>
+            <a:ext cx="10972080" cy="3977280"/>
           </a:xfrm>
           <a:prstGeom prst="rect">
             <a:avLst/>
@@ -1406,7 +1408,7 @@
               </a:lnSpc>
               <a:buNone/>
             </a:pPr>
-            <a:fld id="{3E7D7024-389C-47F9-9F73-840EAB3F20E9}" type="slidenum">
+            <a:fld id="{1DD8CA94-CDB5-4E16-89FC-AFCD2709D137}" type="slidenum">
               <a:rPr lang="en-US" sz="1200" b="0" u="none" strike="noStrike">
                 <a:solidFill>
                   <a:schemeClr val="dk1">
@@ -1865,7 +1867,7 @@
               </a:lnSpc>
               <a:buNone/>
             </a:pPr>
-            <a:fld id="{236F792D-C9CA-4267-83B3-3EEC2F9E8C2C}" type="slidenum">
+            <a:fld id="{89C19A1F-3B8C-440D-BA97-82546076871B}" type="slidenum">
               <a:rPr lang="en-US" sz="1200" b="0" u="none" strike="noStrike">
                 <a:solidFill>
                   <a:schemeClr val="dk1">
@@ -1898,8 +1900,8 @@
 </file>
 
 <file path=ppt/slideLayouts/slideLayout12.xml><?xml version="1.0" encoding="utf-8"?>
-<p:sldLayout xmlns:a="http://schemas.openxmlformats.org/drawingml/2006/main" xmlns:p="http://schemas.openxmlformats.org/presentationml/2006/main" xmlns:r="http://schemas.openxmlformats.org/officeDocument/2006/relationships" xmlns:p14="http://schemas.microsoft.com/office/powerpoint/2010/main" xmlns:p15="http://schemas.microsoft.com/office/powerpoint/2012/main" xmlns:mc="http://schemas.openxmlformats.org/markup-compatibility/2006" type="tx" preserve="1">
-  <p:cSld name="Vintage">
+<p:sldLayout xmlns:a="http://schemas.openxmlformats.org/drawingml/2006/main" xmlns:p="http://schemas.openxmlformats.org/presentationml/2006/main" xmlns:r="http://schemas.openxmlformats.org/officeDocument/2006/relationships" xmlns:p14="http://schemas.microsoft.com/office/powerpoint/2010/main" xmlns:p15="http://schemas.microsoft.com/office/powerpoint/2012/main" xmlns:mc="http://schemas.openxmlformats.org/markup-compatibility/2006" type="title" preserve="1">
+  <p:cSld name="Blue_Curve">
     <p:spTree>
       <p:nvGrpSpPr>
         <p:cNvPr id="1" name=""/>
@@ -1926,8 +1928,8 @@
         </p:nvSpPr>
         <p:spPr>
           <a:xfrm>
-            <a:off x="457200" y="2873520"/>
-            <a:ext cx="8229600" cy="1144800"/>
+            <a:off x="0" y="1959120"/>
+            <a:ext cx="10885680" cy="1306440"/>
           </a:xfrm>
           <a:prstGeom prst="rect">
             <a:avLst/>
@@ -1939,7 +1941,7 @@
         </p:spPr>
         <p:txBody>
           <a:bodyPr lIns="0" tIns="0" rIns="0" bIns="0" anchor="ctr">
-            <a:normAutofit/>
+            <a:spAutoFit/>
           </a:bodyPr>
           <a:p>
             <a:pPr indent="0" algn="ctr">
@@ -1947,7 +1949,7 @@
             </a:pPr>
             <a:endParaRPr lang="en-US" sz="3750" b="0" u="none" strike="noStrike">
               <a:solidFill>
-                <a:srgbClr val="000000"/>
+                <a:srgbClr val="DD4100"/>
               </a:solidFill>
               <a:effectLst/>
               <a:uFillTx/>
@@ -1963,13 +1965,13 @@
             <a:spLocks noGrp="1"/>
           </p:cNvSpPr>
           <p:nvPr>
-            <p:ph/>
+            <p:ph type="subTitle"/>
           </p:nvPr>
         </p:nvSpPr>
         <p:spPr>
           <a:xfrm>
-            <a:off x="457200" y="4310640"/>
-            <a:ext cx="8229600" cy="2883240"/>
+            <a:off x="435240" y="3483000"/>
+            <a:ext cx="11320920" cy="2049120"/>
           </a:xfrm>
           <a:prstGeom prst="rect">
             <a:avLst/>
@@ -1980,21 +1982,21 @@
           </a:ln>
         </p:spPr>
         <p:txBody>
-          <a:bodyPr lIns="0" tIns="0" rIns="0" bIns="0" anchor="t">
-            <a:normAutofit/>
+          <a:bodyPr lIns="0" tIns="0" rIns="0" bIns="0" anchor="ctr">
+            <a:spAutoFit/>
           </a:bodyPr>
           <a:p>
             <a:pPr indent="0" algn="ctr">
-              <a:spcAft>
-                <a:spcPts val="1281"/>
-              </a:spcAft>
-              <a:buNone/>
-            </a:pPr>
-            <a:endParaRPr lang="en-US" sz="2900" b="0" u="none" strike="noStrike">
-              <a:solidFill>
-                <a:srgbClr val="000000"/>
-              </a:solidFill>
-              <a:effectLst/>
+              <a:buNone/>
+            </a:pPr>
+            <a:endParaRPr lang="en-US" sz="3200" b="0" u="none" strike="noStrike">
+              <a:solidFill>
+                <a:srgbClr val="000000"/>
+              </a:solidFill>
+              <a:effectLst/>
+              <a:highlight>
+                <a:srgbClr val="FFFFFF"/>
+              </a:highlight>
               <a:uFillTx/>
               <a:latin typeface="Times New Roman"/>
             </a:endParaRPr>
@@ -2035,7 +2037,7 @@
         <p:txBody>
           <a:bodyPr/>
           <a:p>
-            <a:fld id="{27C04793-E9B9-4794-AA46-6E22B06DFE09}" type="slidenum">
+            <a:fld id="{55E8D113-7C1E-48BF-A604-FD029E226397}" type="slidenum">
               <a:t>&lt;#&gt;</a:t>
             </a:fld>
           </a:p>
@@ -2072,7 +2074,7 @@
 
 <file path=ppt/slideLayouts/slideLayout13.xml><?xml version="1.0" encoding="utf-8"?>
 <p:sldLayout xmlns:a="http://schemas.openxmlformats.org/drawingml/2006/main" xmlns:p="http://schemas.openxmlformats.org/presentationml/2006/main" xmlns:r="http://schemas.openxmlformats.org/officeDocument/2006/relationships" xmlns:p14="http://schemas.microsoft.com/office/powerpoint/2010/main" xmlns:p15="http://schemas.microsoft.com/office/powerpoint/2012/main" xmlns:mc="http://schemas.openxmlformats.org/markup-compatibility/2006" type="obj" preserve="1">
-  <p:cSld name="Vintage">
+  <p:cSld name="Blue_Curve">
     <p:spTree>
       <p:nvGrpSpPr>
         <p:cNvPr id="1" name=""/>
@@ -2099,8 +2101,8 @@
         </p:nvSpPr>
         <p:spPr>
           <a:xfrm>
-            <a:off x="457200" y="2873520"/>
-            <a:ext cx="8229600" cy="1144800"/>
+            <a:off x="0" y="1959120"/>
+            <a:ext cx="10885680" cy="1306440"/>
           </a:xfrm>
           <a:prstGeom prst="rect">
             <a:avLst/>
@@ -2112,7 +2114,7 @@
         </p:spPr>
         <p:txBody>
           <a:bodyPr lIns="0" tIns="0" rIns="0" bIns="0" anchor="ctr">
-            <a:normAutofit/>
+            <a:spAutoFit/>
           </a:bodyPr>
           <a:p>
             <a:pPr indent="0" algn="ctr">
@@ -2120,7 +2122,7 @@
             </a:pPr>
             <a:endParaRPr lang="en-US" sz="3750" b="0" u="none" strike="noStrike">
               <a:solidFill>
-                <a:srgbClr val="000000"/>
+                <a:srgbClr val="DD4100"/>
               </a:solidFill>
               <a:effectLst/>
               <a:uFillTx/>
@@ -2141,8 +2143,8 @@
         </p:nvSpPr>
         <p:spPr>
           <a:xfrm>
-            <a:off x="457200" y="4310640"/>
-            <a:ext cx="8229600" cy="2883240"/>
+            <a:off x="435240" y="3483000"/>
+            <a:ext cx="11320920" cy="2049120"/>
           </a:xfrm>
           <a:prstGeom prst="rect">
             <a:avLst/>
@@ -2157,15 +2159,15 @@
             <a:normAutofit/>
           </a:bodyPr>
           <a:p>
-            <a:pPr indent="0" algn="ctr">
-              <a:spcAft>
+            <a:pPr indent="0" algn="l">
+              <a:spcBef>
                 <a:spcPts val="1281"/>
-              </a:spcAft>
+              </a:spcBef>
               <a:buNone/>
             </a:pPr>
             <a:endParaRPr lang="en-US" sz="2900" b="0" u="none" strike="noStrike">
               <a:solidFill>
-                <a:srgbClr val="000000"/>
+                <a:srgbClr val="009BDD"/>
               </a:solidFill>
               <a:effectLst/>
               <a:uFillTx/>
@@ -2208,177 +2210,7 @@
         <p:txBody>
           <a:bodyPr/>
           <a:p>
-            <a:fld id="{BB2D3AAA-035B-43FD-BE87-20DC4DAFE334}" type="slidenum">
-              <a:t>&lt;#&gt;</a:t>
-            </a:fld>
-          </a:p>
-        </p:txBody>
-      </p:sp>
-      <p:sp>
-        <p:nvSpPr>
-          <p:cNvPr id="6" name="PlaceHolder 5"/>
-          <p:cNvSpPr>
-            <a:spLocks noGrp="1"/>
-          </p:cNvSpPr>
-          <p:nvPr>
-            <p:ph type="dt" idx="34"/>
-          </p:nvPr>
-        </p:nvSpPr>
-        <p:spPr/>
-        <p:txBody>
-          <a:bodyPr/>
-          <a:p>
-            <a:r>
-              <a:rPr lang="en-US"/>
-              <a:t/>
-            </a:r>
-          </a:p>
-        </p:txBody>
-      </p:sp>
-    </p:spTree>
-  </p:cSld>
-  <p:clrMapOvr>
-    <a:masterClrMapping/>
-  </p:clrMapOvr>
-</p:sldLayout>
-</file>
-
-<file path=ppt/slideLayouts/slideLayout14.xml><?xml version="1.0" encoding="utf-8"?>
-<p:sldLayout xmlns:a="http://schemas.openxmlformats.org/drawingml/2006/main" xmlns:p="http://schemas.openxmlformats.org/presentationml/2006/main" xmlns:r="http://schemas.openxmlformats.org/officeDocument/2006/relationships" xmlns:p14="http://schemas.microsoft.com/office/powerpoint/2010/main" xmlns:p15="http://schemas.microsoft.com/office/powerpoint/2012/main" xmlns:mc="http://schemas.openxmlformats.org/markup-compatibility/2006" type="title" preserve="1">
-  <p:cSld name="Vintage">
-    <p:spTree>
-      <p:nvGrpSpPr>
-        <p:cNvPr id="1" name=""/>
-        <p:cNvGrpSpPr/>
-        <p:nvPr/>
-      </p:nvGrpSpPr>
-      <p:grpSpPr>
-        <a:xfrm>
-          <a:off x="0" y="0"/>
-          <a:ext cx="0" cy="0"/>
-          <a:chOff x="0" y="0"/>
-          <a:chExt cx="0" cy="0"/>
-        </a:xfrm>
-      </p:grpSpPr>
-      <p:sp>
-        <p:nvSpPr>
-          <p:cNvPr id="70" name="PlaceHolder 1"/>
-          <p:cNvSpPr>
-            <a:spLocks noGrp="1"/>
-          </p:cNvSpPr>
-          <p:nvPr>
-            <p:ph type="title"/>
-          </p:nvPr>
-        </p:nvSpPr>
-        <p:spPr>
-          <a:xfrm>
-            <a:off x="457200" y="2873520"/>
-            <a:ext cx="8229600" cy="1144800"/>
-          </a:xfrm>
-          <a:prstGeom prst="rect">
-            <a:avLst/>
-          </a:prstGeom>
-          <a:noFill/>
-          <a:ln w="0">
-            <a:noFill/>
-          </a:ln>
-        </p:spPr>
-        <p:txBody>
-          <a:bodyPr lIns="0" tIns="0" rIns="0" bIns="0" anchor="ctr">
-            <a:normAutofit/>
-          </a:bodyPr>
-          <a:p>
-            <a:pPr indent="0" algn="ctr">
-              <a:buNone/>
-            </a:pPr>
-            <a:endParaRPr lang="en-US" sz="3750" b="0" u="none" strike="noStrike">
-              <a:solidFill>
-                <a:srgbClr val="000000"/>
-              </a:solidFill>
-              <a:effectLst/>
-              <a:uFillTx/>
-              <a:latin typeface="Times New Roman"/>
-            </a:endParaRPr>
-          </a:p>
-        </p:txBody>
-      </p:sp>
-      <p:sp>
-        <p:nvSpPr>
-          <p:cNvPr id="71" name="PlaceHolder 2"/>
-          <p:cNvSpPr>
-            <a:spLocks noGrp="1"/>
-          </p:cNvSpPr>
-          <p:nvPr>
-            <p:ph type="subTitle"/>
-          </p:nvPr>
-        </p:nvSpPr>
-        <p:spPr>
-          <a:xfrm>
-            <a:off x="457200" y="4310640"/>
-            <a:ext cx="8229600" cy="2883240"/>
-          </a:xfrm>
-          <a:prstGeom prst="rect">
-            <a:avLst/>
-          </a:prstGeom>
-          <a:noFill/>
-          <a:ln w="0">
-            <a:noFill/>
-          </a:ln>
-        </p:spPr>
-        <p:txBody>
-          <a:bodyPr lIns="0" tIns="0" rIns="0" bIns="0" anchor="ctr">
-            <a:spAutoFit/>
-          </a:bodyPr>
-          <a:p>
-            <a:pPr indent="0" algn="ctr">
-              <a:buNone/>
-            </a:pPr>
-            <a:endParaRPr lang="en-US" sz="3200" b="0" u="none" strike="noStrike">
-              <a:solidFill>
-                <a:srgbClr val="000000"/>
-              </a:solidFill>
-              <a:effectLst/>
-              <a:uFillTx/>
-              <a:latin typeface="Times New Roman"/>
-            </a:endParaRPr>
-          </a:p>
-        </p:txBody>
-      </p:sp>
-      <p:sp>
-        <p:nvSpPr>
-          <p:cNvPr id="4" name="PlaceHolder 3"/>
-          <p:cNvSpPr>
-            <a:spLocks noGrp="1"/>
-          </p:cNvSpPr>
-          <p:nvPr>
-            <p:ph type="ftr" idx="35"/>
-          </p:nvPr>
-        </p:nvSpPr>
-        <p:spPr/>
-        <p:txBody>
-          <a:bodyPr/>
-          <a:p>
-            <a:r>
-              <a:t>Footer</a:t>
-            </a:r>
-          </a:p>
-        </p:txBody>
-      </p:sp>
-      <p:sp>
-        <p:nvSpPr>
-          <p:cNvPr id="5" name="PlaceHolder 4"/>
-          <p:cNvSpPr>
-            <a:spLocks noGrp="1"/>
-          </p:cNvSpPr>
-          <p:nvPr>
-            <p:ph type="sldNum" idx="36"/>
-          </p:nvPr>
-        </p:nvSpPr>
-        <p:spPr/>
-        <p:txBody>
-          <a:bodyPr/>
-          <a:p>
-            <a:fld id="{7846138A-DEC3-4834-87F0-E30D94F689C0}" type="slidenum">
+            <a:fld id="{AFDA6F01-6180-4743-9609-6913C831050C}" type="slidenum">
               <a:t>&lt;#&gt;</a:t>
             </a:fld>
           </a:p>
@@ -3009,7 +2841,7 @@
               </a:lnSpc>
               <a:buNone/>
             </a:pPr>
-            <a:fld id="{A8CF160C-CEE7-43F2-985F-3C8E4E158690}" type="slidenum">
+            <a:fld id="{EBD34BD0-0AA3-48B9-BCA7-639D8C23987D}" type="slidenum">
               <a:rPr lang="en-US" sz="1200" b="0" u="none" strike="noStrike">
                 <a:solidFill>
                   <a:schemeClr val="dk1">
@@ -3637,7 +3469,7 @@
               </a:lnSpc>
               <a:buNone/>
             </a:pPr>
-            <a:fld id="{3FE2ABED-FF13-4EBF-8959-C3973E27F9AA}" type="slidenum">
+            <a:fld id="{D901E141-E502-4E7C-8FB4-F544C5414653}" type="slidenum">
               <a:rPr lang="en-US" sz="1200" b="0" u="none" strike="noStrike">
                 <a:solidFill>
                   <a:schemeClr val="dk1">
@@ -4265,7 +4097,7 @@
               </a:lnSpc>
               <a:buNone/>
             </a:pPr>
-            <a:fld id="{D1AE2CAD-959F-4C83-A338-6DA401F4E7C7}" type="slidenum">
+            <a:fld id="{AFAA4E4C-28AE-4D74-A84B-66F98954DF6B}" type="slidenum">
               <a:rPr lang="en-US" sz="1200" b="0" u="none" strike="noStrike">
                 <a:solidFill>
                   <a:schemeClr val="dk1">
@@ -4677,7 +4509,7 @@
               </a:lnSpc>
               <a:buNone/>
             </a:pPr>
-            <a:fld id="{830F9ADD-F8A5-4D7E-B195-0895585DCC37}" type="slidenum">
+            <a:fld id="{4E8CFF2C-AF5A-4415-920E-681A8AD0F6AE}" type="slidenum">
               <a:rPr lang="en-US" sz="1200" b="0" u="none" strike="noStrike">
                 <a:solidFill>
                   <a:schemeClr val="dk1">
@@ -5611,7 +5443,7 @@
               </a:lnSpc>
               <a:buNone/>
             </a:pPr>
-            <a:fld id="{9C7992CF-2AA5-4054-A9BC-8A2E9B774C6B}" type="slidenum">
+            <a:fld id="{1AE6CFEA-7667-4098-8CC2-BB53920F8527}" type="slidenum">
               <a:rPr lang="en-US" sz="1200" b="0" u="none" strike="noStrike">
                 <a:solidFill>
                   <a:schemeClr val="dk1">
@@ -6773,7 +6605,7 @@
               </a:lnSpc>
               <a:buNone/>
             </a:pPr>
-            <a:fld id="{FE930850-376C-4BF3-8695-D08276E57707}" type="slidenum">
+            <a:fld id="{8C065B8A-45F3-43E3-B801-FC6291DF6158}" type="slidenum">
               <a:rPr lang="en-US" sz="1200" b="0" u="none" strike="noStrike">
                 <a:solidFill>
                   <a:schemeClr val="dk1">
@@ -7095,7 +6927,7 @@
               </a:lnSpc>
               <a:buNone/>
             </a:pPr>
-            <a:fld id="{38147347-6F3D-4A91-97D0-FB2DC23D2B3D}" type="slidenum">
+            <a:fld id="{6DA761DB-4499-4733-95A3-00124195D095}" type="slidenum">
               <a:rPr lang="en-US" sz="1200" b="0" u="none" strike="noStrike">
                 <a:solidFill>
                   <a:schemeClr val="dk1">
@@ -7345,7 +7177,7 @@
               </a:lnSpc>
               <a:buNone/>
             </a:pPr>
-            <a:fld id="{18C1F05B-04A7-4FB4-94BA-690849DEC096}" type="slidenum">
+            <a:fld id="{79039D8D-0D23-4497-9215-B5BFB4111BA8}" type="slidenum">
               <a:rPr lang="en-US" sz="1200" b="0" u="none" strike="noStrike">
                 <a:solidFill>
                   <a:schemeClr val="dk1">
@@ -7430,30 +7262,441 @@
           <a:chExt cx="0" cy="0"/>
         </a:xfrm>
       </p:grpSpPr>
-      <p:pic>
-        <p:nvPicPr>
+      <p:sp>
+        <p:nvSpPr>
           <p:cNvPr id="60" name=""/>
-          <p:cNvPicPr/>
+          <p:cNvSpPr/>
           <p:nvPr/>
-        </p:nvPicPr>
-        <p:blipFill>
-          <a:blip r:embed="rId2"/>
-          <a:stretch/>
-        </p:blipFill>
+        </p:nvSpPr>
         <p:spPr>
-          <a:xfrm>
-            <a:off x="0" y="0"/>
-            <a:ext cx="9144000" cy="6858000"/>
+          <a:xfrm flipH="1" flipV="1">
+            <a:off x="0" y="5442120"/>
+            <a:ext cx="12191760" cy="1415160"/>
           </a:xfrm>
-          <a:prstGeom prst="rect">
+          <a:prstGeom prst="flowChartDocument">
             <a:avLst/>
           </a:prstGeom>
-          <a:noFill/>
+          <a:gradFill rotWithShape="0">
+            <a:gsLst>
+              <a:gs pos="0">
+                <a:srgbClr val="77CAEE"/>
+              </a:gs>
+              <a:gs pos="1563">
+                <a:srgbClr val="77CAEE"/>
+              </a:gs>
+              <a:gs pos="1563">
+                <a:srgbClr val="75C9EE"/>
+              </a:gs>
+              <a:gs pos="3125">
+                <a:srgbClr val="75C9EE"/>
+              </a:gs>
+              <a:gs pos="3125">
+                <a:srgbClr val="73C9ED"/>
+              </a:gs>
+              <a:gs pos="4688">
+                <a:srgbClr val="73C9ED"/>
+              </a:gs>
+              <a:gs pos="4688">
+                <a:srgbClr val="71C8ED"/>
+              </a:gs>
+              <a:gs pos="6250">
+                <a:srgbClr val="71C8ED"/>
+              </a:gs>
+              <a:gs pos="6250">
+                <a:srgbClr val="6FC7ED"/>
+              </a:gs>
+              <a:gs pos="7813">
+                <a:srgbClr val="6FC7ED"/>
+              </a:gs>
+              <a:gs pos="7813">
+                <a:srgbClr val="6EC6ED"/>
+              </a:gs>
+              <a:gs pos="9375">
+                <a:srgbClr val="6EC6ED"/>
+              </a:gs>
+              <a:gs pos="9375">
+                <a:srgbClr val="6CC6EC"/>
+              </a:gs>
+              <a:gs pos="10938">
+                <a:srgbClr val="6CC6EC"/>
+              </a:gs>
+              <a:gs pos="10938">
+                <a:srgbClr val="6AC5EC"/>
+              </a:gs>
+              <a:gs pos="12500">
+                <a:srgbClr val="6AC5EC"/>
+              </a:gs>
+              <a:gs pos="12500">
+                <a:srgbClr val="68C4EC"/>
+              </a:gs>
+              <a:gs pos="14063">
+                <a:srgbClr val="68C4EC"/>
+              </a:gs>
+              <a:gs pos="14063">
+                <a:srgbClr val="66C3EC"/>
+              </a:gs>
+              <a:gs pos="15625">
+                <a:srgbClr val="66C3EC"/>
+              </a:gs>
+              <a:gs pos="15625">
+                <a:srgbClr val="64C3EB"/>
+              </a:gs>
+              <a:gs pos="17188">
+                <a:srgbClr val="64C3EB"/>
+              </a:gs>
+              <a:gs pos="17188">
+                <a:srgbClr val="62C2EB"/>
+              </a:gs>
+              <a:gs pos="18750">
+                <a:srgbClr val="62C2EB"/>
+              </a:gs>
+              <a:gs pos="18750">
+                <a:srgbClr val="60C1EB"/>
+              </a:gs>
+              <a:gs pos="20313">
+                <a:srgbClr val="60C1EB"/>
+              </a:gs>
+              <a:gs pos="20313">
+                <a:srgbClr val="5EC0EA"/>
+              </a:gs>
+              <a:gs pos="21875">
+                <a:srgbClr val="5EC0EA"/>
+              </a:gs>
+              <a:gs pos="21875">
+                <a:srgbClr val="5DC0EA"/>
+              </a:gs>
+              <a:gs pos="23438">
+                <a:srgbClr val="5DC0EA"/>
+              </a:gs>
+              <a:gs pos="23438">
+                <a:srgbClr val="5BBFEA"/>
+              </a:gs>
+              <a:gs pos="25000">
+                <a:srgbClr val="5BBFEA"/>
+              </a:gs>
+              <a:gs pos="25000">
+                <a:srgbClr val="59BEEA"/>
+              </a:gs>
+              <a:gs pos="26563">
+                <a:srgbClr val="59BEEA"/>
+              </a:gs>
+              <a:gs pos="26563">
+                <a:srgbClr val="57BDE9"/>
+              </a:gs>
+              <a:gs pos="28125">
+                <a:srgbClr val="57BDE9"/>
+              </a:gs>
+              <a:gs pos="28125">
+                <a:srgbClr val="55BDE9"/>
+              </a:gs>
+              <a:gs pos="29688">
+                <a:srgbClr val="55BDE9"/>
+              </a:gs>
+              <a:gs pos="29688">
+                <a:srgbClr val="53BCE9"/>
+              </a:gs>
+              <a:gs pos="31250">
+                <a:srgbClr val="53BCE9"/>
+              </a:gs>
+              <a:gs pos="31250">
+                <a:srgbClr val="51BBE9"/>
+              </a:gs>
+              <a:gs pos="32813">
+                <a:srgbClr val="51BBE9"/>
+              </a:gs>
+              <a:gs pos="32813">
+                <a:srgbClr val="4FBAE8"/>
+              </a:gs>
+              <a:gs pos="34375">
+                <a:srgbClr val="4FBAE8"/>
+              </a:gs>
+              <a:gs pos="34375">
+                <a:srgbClr val="4DBAE8"/>
+              </a:gs>
+              <a:gs pos="35938">
+                <a:srgbClr val="4DBAE8"/>
+              </a:gs>
+              <a:gs pos="35938">
+                <a:srgbClr val="4CB9E8"/>
+              </a:gs>
+              <a:gs pos="37500">
+                <a:srgbClr val="4CB9E8"/>
+              </a:gs>
+              <a:gs pos="37500">
+                <a:srgbClr val="4AB8E8"/>
+              </a:gs>
+              <a:gs pos="39063">
+                <a:srgbClr val="4AB8E8"/>
+              </a:gs>
+              <a:gs pos="39063">
+                <a:srgbClr val="48B7E7"/>
+              </a:gs>
+              <a:gs pos="40625">
+                <a:srgbClr val="48B7E7"/>
+              </a:gs>
+              <a:gs pos="40625">
+                <a:srgbClr val="46B7E7"/>
+              </a:gs>
+              <a:gs pos="42188">
+                <a:srgbClr val="46B7E7"/>
+              </a:gs>
+              <a:gs pos="42188">
+                <a:srgbClr val="44B6E7"/>
+              </a:gs>
+              <a:gs pos="43750">
+                <a:srgbClr val="44B6E7"/>
+              </a:gs>
+              <a:gs pos="43750">
+                <a:srgbClr val="42B5E6"/>
+              </a:gs>
+              <a:gs pos="45313">
+                <a:srgbClr val="42B5E6"/>
+              </a:gs>
+              <a:gs pos="45313">
+                <a:srgbClr val="40B4E6"/>
+              </a:gs>
+              <a:gs pos="46875">
+                <a:srgbClr val="40B4E6"/>
+              </a:gs>
+              <a:gs pos="46875">
+                <a:srgbClr val="3EB4E6"/>
+              </a:gs>
+              <a:gs pos="48438">
+                <a:srgbClr val="3EB4E6"/>
+              </a:gs>
+              <a:gs pos="48438">
+                <a:srgbClr val="3CB3E6"/>
+              </a:gs>
+              <a:gs pos="50000">
+                <a:srgbClr val="3CB3E6"/>
+              </a:gs>
+              <a:gs pos="50000">
+                <a:srgbClr val="3BB2E5"/>
+              </a:gs>
+              <a:gs pos="51563">
+                <a:srgbClr val="3BB2E5"/>
+              </a:gs>
+              <a:gs pos="51563">
+                <a:srgbClr val="39B1E5"/>
+              </a:gs>
+              <a:gs pos="53125">
+                <a:srgbClr val="39B1E5"/>
+              </a:gs>
+              <a:gs pos="53125">
+                <a:srgbClr val="37B1E5"/>
+              </a:gs>
+              <a:gs pos="54688">
+                <a:srgbClr val="37B1E5"/>
+              </a:gs>
+              <a:gs pos="54688">
+                <a:srgbClr val="35B0E5"/>
+              </a:gs>
+              <a:gs pos="56250">
+                <a:srgbClr val="35B0E5"/>
+              </a:gs>
+              <a:gs pos="56250">
+                <a:srgbClr val="33AFE4"/>
+              </a:gs>
+              <a:gs pos="57813">
+                <a:srgbClr val="33AFE4"/>
+              </a:gs>
+              <a:gs pos="57813">
+                <a:srgbClr val="31AEE4"/>
+              </a:gs>
+              <a:gs pos="59375">
+                <a:srgbClr val="31AEE4"/>
+              </a:gs>
+              <a:gs pos="59375">
+                <a:srgbClr val="2FAEE4"/>
+              </a:gs>
+              <a:gs pos="60938">
+                <a:srgbClr val="2FAEE4"/>
+              </a:gs>
+              <a:gs pos="60938">
+                <a:srgbClr val="2DADE3"/>
+              </a:gs>
+              <a:gs pos="62500">
+                <a:srgbClr val="2DADE3"/>
+              </a:gs>
+              <a:gs pos="62500">
+                <a:srgbClr val="2BACE3"/>
+              </a:gs>
+              <a:gs pos="64063">
+                <a:srgbClr val="2BACE3"/>
+              </a:gs>
+              <a:gs pos="64063">
+                <a:srgbClr val="2AABE3"/>
+              </a:gs>
+              <a:gs pos="65625">
+                <a:srgbClr val="2AABE3"/>
+              </a:gs>
+              <a:gs pos="65625">
+                <a:srgbClr val="28ABE3"/>
+              </a:gs>
+              <a:gs pos="67188">
+                <a:srgbClr val="28ABE3"/>
+              </a:gs>
+              <a:gs pos="67188">
+                <a:srgbClr val="26AAE2"/>
+              </a:gs>
+              <a:gs pos="68750">
+                <a:srgbClr val="26AAE2"/>
+              </a:gs>
+              <a:gs pos="68750">
+                <a:srgbClr val="24A9E2"/>
+              </a:gs>
+              <a:gs pos="70313">
+                <a:srgbClr val="24A9E2"/>
+              </a:gs>
+              <a:gs pos="70313">
+                <a:srgbClr val="22A8E2"/>
+              </a:gs>
+              <a:gs pos="71875">
+                <a:srgbClr val="22A8E2"/>
+              </a:gs>
+              <a:gs pos="71875">
+                <a:srgbClr val="20A8E2"/>
+              </a:gs>
+              <a:gs pos="73438">
+                <a:srgbClr val="20A8E2"/>
+              </a:gs>
+              <a:gs pos="73438">
+                <a:srgbClr val="1EA7E1"/>
+              </a:gs>
+              <a:gs pos="75000">
+                <a:srgbClr val="1EA7E1"/>
+              </a:gs>
+              <a:gs pos="75000">
+                <a:srgbClr val="1CA6E1"/>
+              </a:gs>
+              <a:gs pos="76563">
+                <a:srgbClr val="1CA6E1"/>
+              </a:gs>
+              <a:gs pos="76563">
+                <a:srgbClr val="1AA5E1"/>
+              </a:gs>
+              <a:gs pos="78125">
+                <a:srgbClr val="1AA5E1"/>
+              </a:gs>
+              <a:gs pos="78125">
+                <a:srgbClr val="19A5E1"/>
+              </a:gs>
+              <a:gs pos="79688">
+                <a:srgbClr val="19A5E1"/>
+              </a:gs>
+              <a:gs pos="79688">
+                <a:srgbClr val="17A4E0"/>
+              </a:gs>
+              <a:gs pos="81250">
+                <a:srgbClr val="17A4E0"/>
+              </a:gs>
+              <a:gs pos="81250">
+                <a:srgbClr val="15A3E0"/>
+              </a:gs>
+              <a:gs pos="82813">
+                <a:srgbClr val="15A3E0"/>
+              </a:gs>
+              <a:gs pos="82813">
+                <a:srgbClr val="13A2E0"/>
+              </a:gs>
+              <a:gs pos="84375">
+                <a:srgbClr val="13A2E0"/>
+              </a:gs>
+              <a:gs pos="84375">
+                <a:srgbClr val="11A2DF"/>
+              </a:gs>
+              <a:gs pos="85938">
+                <a:srgbClr val="11A2DF"/>
+              </a:gs>
+              <a:gs pos="85938">
+                <a:srgbClr val="0FA1DF"/>
+              </a:gs>
+              <a:gs pos="87500">
+                <a:srgbClr val="0FA1DF"/>
+              </a:gs>
+              <a:gs pos="87500">
+                <a:srgbClr val="0DA0DF"/>
+              </a:gs>
+              <a:gs pos="89063">
+                <a:srgbClr val="0DA0DF"/>
+              </a:gs>
+              <a:gs pos="89063">
+                <a:srgbClr val="0B9FDF"/>
+              </a:gs>
+              <a:gs pos="90625">
+                <a:srgbClr val="0B9FDF"/>
+              </a:gs>
+              <a:gs pos="90625">
+                <a:srgbClr val="099FDE"/>
+              </a:gs>
+              <a:gs pos="92188">
+                <a:srgbClr val="099FDE"/>
+              </a:gs>
+              <a:gs pos="92188">
+                <a:srgbClr val="089EDE"/>
+              </a:gs>
+              <a:gs pos="93750">
+                <a:srgbClr val="089EDE"/>
+              </a:gs>
+              <a:gs pos="93750">
+                <a:srgbClr val="069DDE"/>
+              </a:gs>
+              <a:gs pos="95313">
+                <a:srgbClr val="069DDE"/>
+              </a:gs>
+              <a:gs pos="95313">
+                <a:srgbClr val="049CDE"/>
+              </a:gs>
+              <a:gs pos="96875">
+                <a:srgbClr val="049CDE"/>
+              </a:gs>
+              <a:gs pos="96875">
+                <a:srgbClr val="029CDD"/>
+              </a:gs>
+              <a:gs pos="98438">
+                <a:srgbClr val="029CDD"/>
+              </a:gs>
+              <a:gs pos="98438">
+                <a:srgbClr val="009BDD"/>
+              </a:gs>
+              <a:gs pos="100000">
+                <a:srgbClr val="009BDD"/>
+              </a:gs>
+            </a:gsLst>
+            <a:lin ang="10800000"/>
+          </a:gradFill>
           <a:ln w="38160">
             <a:noFill/>
           </a:ln>
+          <a:effectLst>
+            <a:outerShdw dist="10800" dir="5400000" rotWithShape="0">
+              <a:srgbClr val="009BDD"/>
+            </a:outerShdw>
+          </a:effectLst>
         </p:spPr>
-      </p:pic>
+        <p:style>
+          <a:lnRef idx="0"/>
+          <a:fillRef idx="0"/>
+          <a:effectRef idx="0"/>
+          <a:fontRef idx="minor"/>
+        </p:style>
+        <p:txBody>
+          <a:bodyPr lIns="90000" tIns="45000" rIns="90000" bIns="45000" anchor="ctr">
+            <a:spAutoFit/>
+          </a:bodyPr>
+          <a:p>
+            <a:pPr/>
+            <a:endParaRPr lang="en-US" sz="1800" b="0" u="none" strike="noStrike">
+              <a:solidFill>
+                <a:srgbClr val="FFFFFF"/>
+              </a:solidFill>
+              <a:effectLst/>
+              <a:uFillTx/>
+              <a:latin typeface="Arial"/>
+            </a:endParaRPr>
+          </a:p>
+        </p:txBody>
+      </p:sp>
       <p:sp>
         <p:nvSpPr>
           <p:cNvPr id="61" name="PlaceHolder 1"/>
@@ -7466,8 +7709,8 @@
         </p:nvSpPr>
         <p:spPr>
           <a:xfrm>
-            <a:off x="457200" y="2873520"/>
-            <a:ext cx="8229600" cy="1144800"/>
+            <a:off x="0" y="1959120"/>
+            <a:ext cx="10885680" cy="1306440"/>
           </a:xfrm>
           <a:prstGeom prst="rect">
             <a:avLst/>
@@ -7479,14 +7722,14 @@
         </p:spPr>
         <p:txBody>
           <a:bodyPr lIns="0" tIns="0" rIns="0" bIns="0" anchor="ctr">
-            <a:normAutofit/>
+            <a:noAutofit/>
           </a:bodyPr>
           <a:lstStyle>
             <a:lvl1pPr indent="0" algn="ctr">
               <a:buNone/>
               <a:defRPr lang="en-US" sz="3750" b="0" u="none" strike="noStrike">
                 <a:solidFill>
-                  <a:srgbClr val="000000"/>
+                  <a:srgbClr val="DD4100"/>
                 </a:solidFill>
                 <a:effectLst/>
                 <a:uFillTx/>
@@ -7501,7 +7744,7 @@
             <a:r>
               <a:rPr lang="en-US" sz="3750" b="0" u="none" strike="noStrike">
                 <a:solidFill>
-                  <a:srgbClr val="000000"/>
+                  <a:srgbClr val="DD4100"/>
                 </a:solidFill>
                 <a:effectLst/>
                 <a:uFillTx/>
@@ -7511,7 +7754,7 @@
             </a:r>
             <a:endParaRPr lang="en-US" sz="3750" b="0" u="none" strike="noStrike">
               <a:solidFill>
-                <a:srgbClr val="000000"/>
+                <a:srgbClr val="DD4100"/>
               </a:solidFill>
               <a:effectLst/>
               <a:uFillTx/>
@@ -7532,8 +7775,8 @@
         </p:nvSpPr>
         <p:spPr>
           <a:xfrm>
-            <a:off x="457200" y="4310640"/>
-            <a:ext cx="8229600" cy="2883240"/>
+            <a:off x="435240" y="3483000"/>
+            <a:ext cx="11320920" cy="2049120"/>
           </a:xfrm>
           <a:prstGeom prst="rect">
             <a:avLst/>
@@ -7552,91 +7795,133 @@
             <a:spAutoFit/>
           </a:bodyPr>
           <a:lstStyle>
-            <a:lvl1pPr indent="0" algn="ctr">
-              <a:spcAft>
+            <a:lvl1pPr algn="l">
+              <a:spcBef>
                 <a:spcPts val="1281"/>
-              </a:spcAft>
+              </a:spcBef>
+              <a:buClr>
+                <a:srgbClr val="77CAEE"/>
+              </a:buClr>
+              <a:buSzPct val="45000"/>
+              <a:buFont typeface="Wingdings" charset="2"/>
+              <a:buChar char=""/>
               <a:defRPr lang="en-US" sz="2900" b="0" u="none" strike="noStrike">
                 <a:solidFill>
-                  <a:srgbClr val="000000"/>
+                  <a:srgbClr val="009BDD"/>
                 </a:solidFill>
                 <a:effectLst/>
                 <a:uFillTx/>
                 <a:latin typeface="Times New Roman"/>
               </a:defRPr>
             </a:lvl1pPr>
-            <a:lvl2pPr lvl="1" indent="0" algn="ctr">
-              <a:spcAft>
-                <a:spcPts val="1023"/>
-              </a:spcAft>
+            <a:lvl2pPr lvl="1" algn="l">
+              <a:spcBef>
+                <a:spcPts val="1026"/>
+              </a:spcBef>
+              <a:buClr>
+                <a:srgbClr val="77CAEE"/>
+              </a:buClr>
+              <a:buSzPct val="45000"/>
+              <a:buFont typeface="Wingdings" charset="2"/>
+              <a:buChar char=""/>
               <a:defRPr lang="en-US" sz="2540" b="0" u="none" strike="noStrike">
                 <a:solidFill>
-                  <a:srgbClr val="000000"/>
+                  <a:srgbClr val="009BDD"/>
                 </a:solidFill>
                 <a:effectLst/>
                 <a:uFillTx/>
                 <a:latin typeface="Times New Roman"/>
               </a:defRPr>
             </a:lvl2pPr>
-            <a:lvl3pPr lvl="2" indent="0" algn="ctr">
-              <a:spcAft>
-                <a:spcPts val="768"/>
-              </a:spcAft>
+            <a:lvl3pPr lvl="2" algn="l">
+              <a:spcBef>
+                <a:spcPts val="765"/>
+              </a:spcBef>
+              <a:buClr>
+                <a:srgbClr val="77CAEE"/>
+              </a:buClr>
+              <a:buSzPct val="45000"/>
+              <a:buFont typeface="Wingdings" charset="2"/>
+              <a:buChar char=""/>
               <a:defRPr lang="en-US" sz="2180" b="0" u="none" strike="noStrike">
                 <a:solidFill>
-                  <a:srgbClr val="000000"/>
+                  <a:srgbClr val="009BDD"/>
                 </a:solidFill>
                 <a:effectLst/>
                 <a:uFillTx/>
                 <a:latin typeface="Times New Roman"/>
               </a:defRPr>
             </a:lvl3pPr>
-            <a:lvl4pPr lvl="3" indent="0" algn="ctr">
-              <a:spcAft>
+            <a:lvl4pPr lvl="3" algn="l">
+              <a:spcBef>
                 <a:spcPts val="507"/>
-              </a:spcAft>
+              </a:spcBef>
+              <a:buClr>
+                <a:srgbClr val="77CAEE"/>
+              </a:buClr>
+              <a:buSzPct val="45000"/>
+              <a:buFont typeface="Wingdings" charset="2"/>
+              <a:buChar char=""/>
               <a:defRPr lang="en-US" sz="1810" b="0" u="none" strike="noStrike">
                 <a:solidFill>
-                  <a:srgbClr val="000000"/>
+                  <a:srgbClr val="009BDD"/>
                 </a:solidFill>
                 <a:effectLst/>
                 <a:uFillTx/>
                 <a:latin typeface="Times New Roman"/>
               </a:defRPr>
             </a:lvl4pPr>
-            <a:lvl5pPr lvl="4" indent="0" algn="ctr">
-              <a:spcAft>
+            <a:lvl5pPr lvl="4" algn="l">
+              <a:spcBef>
                 <a:spcPts val="252"/>
-              </a:spcAft>
-              <a:defRPr lang="en-US" sz="1810" b="0" u="none" strike="noStrike">
-                <a:solidFill>
-                  <a:srgbClr val="000000"/>
+              </a:spcBef>
+              <a:buClr>
+                <a:srgbClr val="77CAEE"/>
+              </a:buClr>
+              <a:buSzPct val="45000"/>
+              <a:buFont typeface="Wingdings" charset="2"/>
+              <a:buChar char=""/>
+              <a:defRPr lang="en-US" sz="2190" b="0" u="none" strike="noStrike">
+                <a:solidFill>
+                  <a:srgbClr val="009BDD"/>
                 </a:solidFill>
                 <a:effectLst/>
                 <a:uFillTx/>
                 <a:latin typeface="Times New Roman"/>
               </a:defRPr>
             </a:lvl5pPr>
-            <a:lvl6pPr lvl="5" indent="0" algn="ctr">
-              <a:spcAft>
-                <a:spcPts val="252"/>
-              </a:spcAft>
-              <a:defRPr lang="en-US" sz="1810" b="0" u="none" strike="noStrike">
-                <a:solidFill>
-                  <a:srgbClr val="000000"/>
+            <a:lvl6pPr lvl="5" algn="l">
+              <a:spcBef>
+                <a:spcPts val="303"/>
+              </a:spcBef>
+              <a:buClr>
+                <a:srgbClr val="77CAEE"/>
+              </a:buClr>
+              <a:buSzPct val="45000"/>
+              <a:buFont typeface="Wingdings" charset="2"/>
+              <a:buChar char=""/>
+              <a:defRPr lang="en-US" sz="2640" b="0" u="none" strike="noStrike">
+                <a:solidFill>
+                  <a:srgbClr val="009BDD"/>
                 </a:solidFill>
                 <a:effectLst/>
                 <a:uFillTx/>
                 <a:latin typeface="Times New Roman"/>
               </a:defRPr>
             </a:lvl6pPr>
-            <a:lvl7pPr lvl="6" indent="0" algn="ctr">
-              <a:spcAft>
-                <a:spcPts val="252"/>
-              </a:spcAft>
-              <a:defRPr lang="en-US" sz="1810" b="0" u="none" strike="noStrike">
-                <a:solidFill>
-                  <a:srgbClr val="000000"/>
+            <a:lvl7pPr lvl="6" algn="l">
+              <a:spcBef>
+                <a:spcPts val="366"/>
+              </a:spcBef>
+              <a:buClr>
+                <a:srgbClr val="77CAEE"/>
+              </a:buClr>
+              <a:buSzPct val="45000"/>
+              <a:buFont typeface="Wingdings" charset="2"/>
+              <a:buChar char=""/>
+              <a:defRPr lang="en-US" sz="3200" b="0" u="none" strike="noStrike">
+                <a:solidFill>
+                  <a:srgbClr val="009BDD"/>
                 </a:solidFill>
                 <a:effectLst/>
                 <a:uFillTx/>
@@ -7645,15 +7930,21 @@
             </a:lvl7pPr>
           </a:lstStyle>
           <a:p>
-            <a:pPr marL="432000" indent="0" algn="ctr">
-              <a:spcAft>
+            <a:pPr marL="432000" indent="-324000" algn="l">
+              <a:spcBef>
                 <a:spcPts val="1281"/>
-              </a:spcAft>
+              </a:spcBef>
+              <a:buClr>
+                <a:srgbClr val="77CAEE"/>
+              </a:buClr>
+              <a:buSzPct val="45000"/>
+              <a:buFont typeface="Wingdings" charset="2"/>
+              <a:buChar char=""/>
             </a:pPr>
             <a:r>
               <a:rPr lang="en-US" sz="2900" b="0" u="none" strike="noStrike">
                 <a:solidFill>
-                  <a:srgbClr val="000000"/>
+                  <a:srgbClr val="009BDD"/>
                 </a:solidFill>
                 <a:effectLst/>
                 <a:uFillTx/>
@@ -7663,7 +7954,7 @@
             </a:r>
             <a:endParaRPr lang="en-US" sz="2900" b="0" u="none" strike="noStrike">
               <a:solidFill>
-                <a:srgbClr val="000000"/>
+                <a:srgbClr val="009BDD"/>
               </a:solidFill>
               <a:effectLst/>
               <a:uFillTx/>
@@ -7671,15 +7962,21 @@
             </a:endParaRPr>
           </a:p>
           <a:p>
-            <a:pPr marL="864000" lvl="1" indent="0" algn="ctr">
-              <a:spcAft>
-                <a:spcPts val="1023"/>
-              </a:spcAft>
+            <a:pPr marL="864000" lvl="1" indent="-324000" algn="l">
+              <a:spcBef>
+                <a:spcPts val="1026"/>
+              </a:spcBef>
+              <a:buClr>
+                <a:srgbClr val="77CAEE"/>
+              </a:buClr>
+              <a:buSzPct val="45000"/>
+              <a:buFont typeface="Wingdings" charset="2"/>
+              <a:buChar char=""/>
             </a:pPr>
             <a:r>
               <a:rPr lang="en-US" sz="2540" b="0" u="none" strike="noStrike">
                 <a:solidFill>
-                  <a:srgbClr val="000000"/>
+                  <a:srgbClr val="009BDD"/>
                 </a:solidFill>
                 <a:effectLst/>
                 <a:uFillTx/>
@@ -7689,7 +7986,7 @@
             </a:r>
             <a:endParaRPr lang="en-US" sz="2540" b="0" u="none" strike="noStrike">
               <a:solidFill>
-                <a:srgbClr val="000000"/>
+                <a:srgbClr val="009BDD"/>
               </a:solidFill>
               <a:effectLst/>
               <a:uFillTx/>
@@ -7697,15 +7994,21 @@
             </a:endParaRPr>
           </a:p>
           <a:p>
-            <a:pPr marL="1296000" lvl="2" indent="0" algn="ctr">
-              <a:spcAft>
-                <a:spcPts val="768"/>
-              </a:spcAft>
+            <a:pPr marL="1296000" lvl="2" indent="-288000" algn="l">
+              <a:spcBef>
+                <a:spcPts val="765"/>
+              </a:spcBef>
+              <a:buClr>
+                <a:srgbClr val="77CAEE"/>
+              </a:buClr>
+              <a:buSzPct val="45000"/>
+              <a:buFont typeface="Wingdings" charset="2"/>
+              <a:buChar char=""/>
             </a:pPr>
             <a:r>
               <a:rPr lang="en-US" sz="2180" b="0" u="none" strike="noStrike">
                 <a:solidFill>
-                  <a:srgbClr val="000000"/>
+                  <a:srgbClr val="009BDD"/>
                 </a:solidFill>
                 <a:effectLst/>
                 <a:uFillTx/>
@@ -7715,7 +8018,7 @@
             </a:r>
             <a:endParaRPr lang="en-US" sz="2180" b="0" u="none" strike="noStrike">
               <a:solidFill>
-                <a:srgbClr val="000000"/>
+                <a:srgbClr val="009BDD"/>
               </a:solidFill>
               <a:effectLst/>
               <a:uFillTx/>
@@ -7723,15 +8026,21 @@
             </a:endParaRPr>
           </a:p>
           <a:p>
-            <a:pPr marL="1728000" lvl="3" indent="0" algn="ctr">
-              <a:spcAft>
+            <a:pPr marL="1728000" lvl="3" indent="-216000" algn="l">
+              <a:spcBef>
                 <a:spcPts val="507"/>
-              </a:spcAft>
+              </a:spcBef>
+              <a:buClr>
+                <a:srgbClr val="77CAEE"/>
+              </a:buClr>
+              <a:buSzPct val="45000"/>
+              <a:buFont typeface="Wingdings" charset="2"/>
+              <a:buChar char=""/>
             </a:pPr>
             <a:r>
               <a:rPr lang="en-US" sz="1810" b="0" u="none" strike="noStrike">
                 <a:solidFill>
-                  <a:srgbClr val="000000"/>
+                  <a:srgbClr val="009BDD"/>
                 </a:solidFill>
                 <a:effectLst/>
                 <a:uFillTx/>
@@ -7741,7 +8050,7 @@
             </a:r>
             <a:endParaRPr lang="en-US" sz="1810" b="0" u="none" strike="noStrike">
               <a:solidFill>
-                <a:srgbClr val="000000"/>
+                <a:srgbClr val="009BDD"/>
               </a:solidFill>
               <a:effectLst/>
               <a:uFillTx/>
@@ -7749,15 +8058,21 @@
             </a:endParaRPr>
           </a:p>
           <a:p>
-            <a:pPr marL="2160000" lvl="4" indent="0" algn="ctr">
-              <a:spcAft>
+            <a:pPr marL="2160000" lvl="4" indent="-216000" algn="l">
+              <a:spcBef>
                 <a:spcPts val="252"/>
-              </a:spcAft>
-            </a:pPr>
-            <a:r>
-              <a:rPr lang="en-US" sz="1810" b="0" u="none" strike="noStrike">
-                <a:solidFill>
-                  <a:srgbClr val="000000"/>
+              </a:spcBef>
+              <a:buClr>
+                <a:srgbClr val="77CAEE"/>
+              </a:buClr>
+              <a:buSzPct val="45000"/>
+              <a:buFont typeface="Wingdings" charset="2"/>
+              <a:buChar char=""/>
+            </a:pPr>
+            <a:r>
+              <a:rPr lang="en-US" sz="2190" b="0" u="none" strike="noStrike">
+                <a:solidFill>
+                  <a:srgbClr val="009BDD"/>
                 </a:solidFill>
                 <a:effectLst/>
                 <a:uFillTx/>
@@ -7765,9 +8080,9 @@
               </a:rPr>
               <a:t>Fifth Outline Level</a:t>
             </a:r>
-            <a:endParaRPr lang="en-US" sz="1810" b="0" u="none" strike="noStrike">
-              <a:solidFill>
-                <a:srgbClr val="000000"/>
+            <a:endParaRPr lang="en-US" sz="2190" b="0" u="none" strike="noStrike">
+              <a:solidFill>
+                <a:srgbClr val="009BDD"/>
               </a:solidFill>
               <a:effectLst/>
               <a:uFillTx/>
@@ -7775,15 +8090,21 @@
             </a:endParaRPr>
           </a:p>
           <a:p>
-            <a:pPr marL="2592000" lvl="5" indent="0" algn="ctr">
-              <a:spcAft>
-                <a:spcPts val="252"/>
-              </a:spcAft>
-            </a:pPr>
-            <a:r>
-              <a:rPr lang="en-US" sz="1810" b="0" u="none" strike="noStrike">
-                <a:solidFill>
-                  <a:srgbClr val="000000"/>
+            <a:pPr marL="2592000" lvl="5" indent="-216000" algn="l">
+              <a:spcBef>
+                <a:spcPts val="303"/>
+              </a:spcBef>
+              <a:buClr>
+                <a:srgbClr val="77CAEE"/>
+              </a:buClr>
+              <a:buSzPct val="45000"/>
+              <a:buFont typeface="Wingdings" charset="2"/>
+              <a:buChar char=""/>
+            </a:pPr>
+            <a:r>
+              <a:rPr lang="en-US" sz="2640" b="0" u="none" strike="noStrike">
+                <a:solidFill>
+                  <a:srgbClr val="009BDD"/>
                 </a:solidFill>
                 <a:effectLst/>
                 <a:uFillTx/>
@@ -7791,9 +8112,9 @@
               </a:rPr>
               <a:t>Sixth Outline Level</a:t>
             </a:r>
-            <a:endParaRPr lang="en-US" sz="1810" b="0" u="none" strike="noStrike">
-              <a:solidFill>
-                <a:srgbClr val="000000"/>
+            <a:endParaRPr lang="en-US" sz="2640" b="0" u="none" strike="noStrike">
+              <a:solidFill>
+                <a:srgbClr val="009BDD"/>
               </a:solidFill>
               <a:effectLst/>
               <a:uFillTx/>
@@ -7801,15 +8122,21 @@
             </a:endParaRPr>
           </a:p>
           <a:p>
-            <a:pPr marL="3024000" lvl="6" indent="0" algn="ctr">
-              <a:spcAft>
-                <a:spcPts val="252"/>
-              </a:spcAft>
-            </a:pPr>
-            <a:r>
-              <a:rPr lang="en-US" sz="1810" b="0" u="none" strike="noStrike">
-                <a:solidFill>
-                  <a:srgbClr val="000000"/>
+            <a:pPr marL="3024000" lvl="6" indent="-216000" algn="l">
+              <a:spcBef>
+                <a:spcPts val="366"/>
+              </a:spcBef>
+              <a:buClr>
+                <a:srgbClr val="77CAEE"/>
+              </a:buClr>
+              <a:buSzPct val="45000"/>
+              <a:buFont typeface="Wingdings" charset="2"/>
+              <a:buChar char=""/>
+            </a:pPr>
+            <a:r>
+              <a:rPr lang="en-US" sz="3200" b="0" u="none" strike="noStrike">
+                <a:solidFill>
+                  <a:srgbClr val="009BDD"/>
                 </a:solidFill>
                 <a:effectLst/>
                 <a:uFillTx/>
@@ -7817,9 +8144,9 @@
               </a:rPr>
               <a:t>Seventh Outline Level</a:t>
             </a:r>
-            <a:endParaRPr lang="en-US" sz="1810" b="0" u="none" strike="noStrike">
-              <a:solidFill>
-                <a:srgbClr val="000000"/>
+            <a:endParaRPr lang="en-US" sz="3200" b="0" u="none" strike="noStrike">
+              <a:solidFill>
+                <a:srgbClr val="009BDD"/>
               </a:solidFill>
               <a:effectLst/>
               <a:uFillTx/>
@@ -7840,8 +8167,8 @@
         </p:nvSpPr>
         <p:spPr>
           <a:xfrm>
-            <a:off x="457200" y="6531120"/>
-            <a:ext cx="2130120" cy="196920"/>
+            <a:off x="435240" y="6313680"/>
+            <a:ext cx="2830320" cy="435600"/>
           </a:xfrm>
           <a:prstGeom prst="rect">
             <a:avLst/>
@@ -7853,14 +8180,14 @@
         </p:spPr>
         <p:txBody>
           <a:bodyPr lIns="0" tIns="0" rIns="0" bIns="0" anchor="t">
-            <a:spAutoFit/>
+            <a:noAutofit/>
           </a:bodyPr>
           <a:lstStyle>
             <a:lvl1pPr indent="0" algn="l">
               <a:buNone/>
               <a:defRPr lang="en-US" sz="1400" b="0" u="none" strike="noStrike">
                 <a:solidFill>
-                  <a:srgbClr val="000000"/>
+                  <a:srgbClr val="FFFFFF"/>
                 </a:solidFill>
                 <a:effectLst/>
                 <a:uFillTx/>
@@ -7875,7 +8202,7 @@
             <a:r>
               <a:rPr lang="en-US" sz="1400" b="0" u="none" strike="noStrike">
                 <a:solidFill>
-                  <a:srgbClr val="000000"/>
+                  <a:srgbClr val="FFFFFF"/>
                 </a:solidFill>
                 <a:effectLst/>
                 <a:uFillTx/>
@@ -7885,7 +8212,7 @@
             </a:r>
             <a:endParaRPr lang="en-US" sz="1400" b="0" u="none" strike="noStrike">
               <a:solidFill>
-                <a:srgbClr val="000000"/>
+                <a:srgbClr val="FFFFFF"/>
               </a:solidFill>
               <a:effectLst/>
               <a:uFillTx/>
@@ -7906,8 +8233,8 @@
         </p:nvSpPr>
         <p:spPr>
           <a:xfrm>
-            <a:off x="3126600" y="6531120"/>
-            <a:ext cx="2898360" cy="196920"/>
+            <a:off x="4136400" y="6313680"/>
+            <a:ext cx="3918960" cy="435600"/>
           </a:xfrm>
           <a:prstGeom prst="rect">
             <a:avLst/>
@@ -7919,14 +8246,14 @@
         </p:spPr>
         <p:txBody>
           <a:bodyPr lIns="0" tIns="0" rIns="0" bIns="0" anchor="t">
-            <a:spAutoFit/>
+            <a:noAutofit/>
           </a:bodyPr>
           <a:lstStyle>
             <a:lvl1pPr indent="0" algn="ctr">
               <a:buNone/>
               <a:defRPr lang="en-US" sz="1400" b="0" u="none" strike="noStrike">
                 <a:solidFill>
-                  <a:srgbClr val="000000"/>
+                  <a:srgbClr val="FFFFFF"/>
                 </a:solidFill>
                 <a:effectLst/>
                 <a:uFillTx/>
@@ -7941,7 +8268,7 @@
             <a:r>
               <a:rPr lang="en-US" sz="1400" b="0" u="none" strike="noStrike">
                 <a:solidFill>
-                  <a:srgbClr val="000000"/>
+                  <a:srgbClr val="FFFFFF"/>
                 </a:solidFill>
                 <a:effectLst/>
                 <a:uFillTx/>
@@ -7951,7 +8278,7 @@
             </a:r>
             <a:endParaRPr lang="en-US" sz="1400" b="0" u="none" strike="noStrike">
               <a:solidFill>
-                <a:srgbClr val="000000"/>
+                <a:srgbClr val="FFFFFF"/>
               </a:solidFill>
               <a:effectLst/>
               <a:uFillTx/>
@@ -7972,8 +8299,8 @@
         </p:nvSpPr>
         <p:spPr>
           <a:xfrm>
-            <a:off x="6555600" y="6531120"/>
-            <a:ext cx="2130120" cy="196920"/>
+            <a:off x="8925840" y="6313680"/>
+            <a:ext cx="2830320" cy="435600"/>
           </a:xfrm>
           <a:prstGeom prst="rect">
             <a:avLst/>
@@ -7985,14 +8312,14 @@
         </p:spPr>
         <p:txBody>
           <a:bodyPr lIns="0" tIns="0" rIns="0" bIns="0" anchor="t">
-            <a:spAutoFit/>
+            <a:noAutofit/>
           </a:bodyPr>
           <a:lstStyle>
             <a:lvl1pPr indent="0" algn="r">
               <a:buNone/>
               <a:defRPr lang="en-US" sz="1400" b="0" u="none" strike="noStrike">
                 <a:solidFill>
-                  <a:srgbClr val="000000"/>
+                  <a:srgbClr val="FFFFFF"/>
                 </a:solidFill>
                 <a:effectLst/>
                 <a:uFillTx/>
@@ -8004,10 +8331,10 @@
             <a:pPr indent="0" algn="r">
               <a:buNone/>
             </a:pPr>
-            <a:fld id="{FB955462-1CFC-45E3-9053-4AB410CB1514}" type="slidenum">
+            <a:fld id="{C73F6BA3-5FD2-4A30-9743-D5BF943B5012}" type="slidenum">
               <a:rPr lang="en-US" sz="1400" b="0" u="none" strike="noStrike">
                 <a:solidFill>
-                  <a:srgbClr val="000000"/>
+                  <a:srgbClr val="FFFFFF"/>
                 </a:solidFill>
                 <a:effectLst/>
                 <a:uFillTx/>
@@ -8017,7 +8344,7 @@
             </a:fld>
             <a:endParaRPr lang="en-US" sz="1400" b="0" u="none" strike="noStrike">
               <a:solidFill>
-                <a:srgbClr val="000000"/>
+                <a:srgbClr val="FFFFFF"/>
               </a:solidFill>
               <a:effectLst/>
               <a:uFillTx/>
@@ -8030,14 +8357,200 @@
   </p:cSld>
   <p:clrMap bg1="lt1" tx1="dk1" bg2="lt2" tx2="dk2" accent1="accent1" accent2="accent2" accent3="accent3" accent4="accent4" accent5="accent5" accent6="accent6" hlink="hlink" folHlink="folHlink"/>
   <p:sldLayoutIdLst>
-    <p:sldLayoutId id="2147483661" r:id="rId3"/>
-    <p:sldLayoutId id="2147483662" r:id="rId4"/>
-    <p:sldLayoutId id="2147483663" r:id="rId5"/>
+    <p:sldLayoutId id="2147483661" r:id="rId2"/>
+    <p:sldLayoutId id="2147483662" r:id="rId3"/>
   </p:sldLayoutIdLst>
 </p:sldMaster>
 </file>
 
 <file path=ppt/slides/slide1.xml><?xml version="1.0" encoding="utf-8"?>
+<p:sld xmlns:a="http://schemas.openxmlformats.org/drawingml/2006/main" xmlns:p="http://schemas.openxmlformats.org/presentationml/2006/main" xmlns:r="http://schemas.openxmlformats.org/officeDocument/2006/relationships" xmlns:p14="http://schemas.microsoft.com/office/powerpoint/2010/main" xmlns:p15="http://schemas.microsoft.com/office/powerpoint/2012/main" xmlns:mc="http://schemas.openxmlformats.org/markup-compatibility/2006">
+  <p:cSld>
+    <p:spTree>
+      <p:nvGrpSpPr>
+        <p:cNvPr id="1" name=""/>
+        <p:cNvGrpSpPr/>
+        <p:nvPr/>
+      </p:nvGrpSpPr>
+      <p:grpSpPr>
+        <a:xfrm>
+          <a:off x="0" y="0"/>
+          <a:ext cx="0" cy="0"/>
+          <a:chOff x="0" y="0"/>
+          <a:chExt cx="0" cy="0"/>
+        </a:xfrm>
+      </p:grpSpPr>
+      <p:sp>
+        <p:nvSpPr>
+          <p:cNvPr id="70" name="PlaceHolder 1"/>
+          <p:cNvSpPr>
+            <a:spLocks noGrp="1"/>
+          </p:cNvSpPr>
+          <p:nvPr>
+            <p:ph type="title"/>
+          </p:nvPr>
+        </p:nvSpPr>
+        <p:spPr>
+          <a:xfrm>
+            <a:off x="685800" y="2130480"/>
+            <a:ext cx="7772040" cy="1469520"/>
+          </a:xfrm>
+          <a:prstGeom prst="rect">
+            <a:avLst/>
+          </a:prstGeom>
+          <a:noFill/>
+          <a:ln w="0">
+            <a:noFill/>
+          </a:ln>
+        </p:spPr>
+        <p:txBody>
+          <a:bodyPr lIns="91440" tIns="45720" rIns="91440" bIns="45720" anchor="ctr">
+            <a:noAutofit/>
+          </a:bodyPr>
+          <a:p>
+            <a:pPr indent="0" algn="ctr" defTabSz="457200">
+              <a:lnSpc>
+                <a:spcPct val="100000"/>
+              </a:lnSpc>
+              <a:buNone/>
+            </a:pPr>
+            <a:r>
+              <a:rPr lang="en-US" sz="4400" b="1" u="none" strike="noStrike">
+                <a:solidFill>
+                  <a:srgbClr val="0D9488"/>
+                </a:solidFill>
+                <a:effectLst/>
+                <a:uFillTx/>
+                <a:latin typeface="Calibri"/>
+              </a:rPr>
+              <a:t>Journey of Resilience &amp; Growth</a:t>
+            </a:r>
+            <a:endParaRPr lang="en-US" sz="4400" b="0" u="none" strike="noStrike">
+              <a:solidFill>
+                <a:srgbClr val="DD4100"/>
+              </a:solidFill>
+              <a:effectLst/>
+              <a:uFillTx/>
+              <a:latin typeface="Times New Roman"/>
+            </a:endParaRPr>
+          </a:p>
+        </p:txBody>
+      </p:sp>
+      <p:sp>
+        <p:nvSpPr>
+          <p:cNvPr id="71" name="PlaceHolder 2"/>
+          <p:cNvSpPr>
+            <a:spLocks noGrp="1"/>
+          </p:cNvSpPr>
+          <p:nvPr>
+            <p:ph type="subTitle"/>
+          </p:nvPr>
+        </p:nvSpPr>
+        <p:spPr>
+          <a:xfrm>
+            <a:off x="1371600" y="3886200"/>
+            <a:ext cx="6400440" cy="1752120"/>
+          </a:xfrm>
+          <a:prstGeom prst="rect">
+            <a:avLst/>
+          </a:prstGeom>
+          <a:noFill/>
+          <a:ln w="0">
+            <a:noFill/>
+          </a:ln>
+        </p:spPr>
+        <p:txBody>
+          <a:bodyPr lIns="91440" tIns="45720" rIns="91440" bIns="45720" anchor="t">
+            <a:noAutofit/>
+          </a:bodyPr>
+          <a:p>
+            <a:pPr indent="0" algn="ctr" defTabSz="457200">
+              <a:lnSpc>
+                <a:spcPct val="100000"/>
+              </a:lnSpc>
+              <a:spcBef>
+                <a:spcPts val="479"/>
+              </a:spcBef>
+              <a:buNone/>
+              <a:tabLst>
+                <a:tab pos="0" algn="l"/>
+              </a:tabLst>
+            </a:pPr>
+            <a:r>
+              <a:rPr lang="en-US" sz="2400" b="0" u="none" strike="noStrike">
+                <a:solidFill>
+                  <a:srgbClr val="64748B"/>
+                </a:solidFill>
+                <a:effectLst/>
+                <a:uFillTx/>
+                <a:latin typeface="Calibri"/>
+              </a:rPr>
+              <a:t>An Autobiographical Presentation by Ngei David Mumo</a:t>
+            </a:r>
+            <a:endParaRPr lang="en-US" sz="2400" b="0" u="none" strike="noStrike">
+              <a:solidFill>
+                <a:srgbClr val="000000"/>
+              </a:solidFill>
+              <a:effectLst/>
+              <a:highlight>
+                <a:srgbClr val="FFFFFF"/>
+              </a:highlight>
+              <a:uFillTx/>
+              <a:latin typeface="Times New Roman"/>
+            </a:endParaRPr>
+          </a:p>
+          <a:p>
+            <a:pPr indent="0" algn="ctr" defTabSz="457200">
+              <a:lnSpc>
+                <a:spcPct val="100000"/>
+              </a:lnSpc>
+              <a:spcBef>
+                <a:spcPts val="479"/>
+              </a:spcBef>
+              <a:buNone/>
+              <a:tabLst>
+                <a:tab pos="0" algn="l"/>
+              </a:tabLst>
+            </a:pPr>
+            <a:r>
+              <a:rPr lang="en-US" sz="2400" b="0" u="none" strike="noStrike">
+                <a:solidFill>
+                  <a:srgbClr val="64748B"/>
+                </a:solidFill>
+                <a:effectLst/>
+                <a:uFillTx/>
+                <a:latin typeface="Calibri"/>
+              </a:rPr>
+              <a:t>Dedan Kimathi University of Technology</a:t>
+            </a:r>
+            <a:endParaRPr lang="en-US" sz="2400" b="0" u="none" strike="noStrike">
+              <a:solidFill>
+                <a:srgbClr val="000000"/>
+              </a:solidFill>
+              <a:effectLst/>
+              <a:highlight>
+                <a:srgbClr val="FFFFFF"/>
+              </a:highlight>
+              <a:uFillTx/>
+              <a:latin typeface="Times New Roman"/>
+            </a:endParaRPr>
+          </a:p>
+        </p:txBody>
+      </p:sp>
+    </p:spTree>
+  </p:cSld>
+  <mc:AlternateContent>
+    <mc:Choice Requires="p14">
+      <p:transition spd="slow" p14:dur="2000"/>
+    </mc:Choice>
+    <mc:Fallback>
+      <p:transition spd="slow"/>
+    </mc:Fallback>
+  </mc:AlternateContent>
+</p:sld>
+</file>
+
+<file path=ppt/slides/slide2.xml><?xml version="1.0" encoding="utf-8"?>
 <p:sld xmlns:a="http://schemas.openxmlformats.org/drawingml/2006/main" xmlns:p="http://schemas.openxmlformats.org/presentationml/2006/main" xmlns:r="http://schemas.openxmlformats.org/officeDocument/2006/relationships" xmlns:p14="http://schemas.microsoft.com/office/powerpoint/2010/main" xmlns:p15="http://schemas.microsoft.com/office/powerpoint/2012/main" xmlns:mc="http://schemas.openxmlformats.org/markup-compatibility/2006">
   <p:cSld>
     <p:spTree>
@@ -8066,8 +8579,8 @@
         </p:nvSpPr>
         <p:spPr>
           <a:xfrm>
-            <a:off x="685800" y="2130480"/>
-            <a:ext cx="7772040" cy="1469520"/>
+            <a:off x="457200" y="274680"/>
+            <a:ext cx="8229240" cy="1142640"/>
           </a:xfrm>
           <a:prstGeom prst="rect">
             <a:avLst/>
@@ -8089,19 +8602,19 @@
               <a:buNone/>
             </a:pPr>
             <a:r>
-              <a:rPr lang="en-US" sz="4400" b="0" u="none" strike="noStrike">
-                <a:solidFill>
-                  <a:schemeClr val="dk1"/>
-                </a:solidFill>
-                <a:effectLst/>
-                <a:uFillTx/>
-                <a:latin typeface="Calibri"/>
-              </a:rPr>
-              <a:t>Ngei David Mumo</a:t>
-            </a:r>
-            <a:endParaRPr lang="en-US" sz="4400" b="0" u="none" strike="noStrike">
-              <a:solidFill>
-                <a:srgbClr val="000000"/>
+              <a:rPr lang="en-US" sz="3200" b="1" u="none" strike="noStrike">
+                <a:solidFill>
+                  <a:srgbClr val="0F766E"/>
+                </a:solidFill>
+                <a:effectLst/>
+                <a:uFillTx/>
+                <a:latin typeface="Calibri"/>
+              </a:rPr>
+              <a:t>1. Roots &amp; Early Upbringing (Kitui County)</a:t>
+            </a:r>
+            <a:endParaRPr lang="en-US" sz="3200" b="0" u="none" strike="noStrike">
+              <a:solidFill>
+                <a:srgbClr val="DD4100"/>
               </a:solidFill>
               <a:effectLst/>
               <a:uFillTx/>
@@ -8117,13 +8630,13 @@
             <a:spLocks noGrp="1"/>
           </p:cNvSpPr>
           <p:nvPr>
-            <p:ph type="subTitle"/>
+            <p:ph/>
           </p:nvPr>
         </p:nvSpPr>
         <p:spPr>
           <a:xfrm>
-            <a:off x="1371600" y="3886200"/>
-            <a:ext cx="6400440" cy="1752120"/>
+            <a:off x="457200" y="1600200"/>
+            <a:ext cx="8229240" cy="4525560"/>
           </a:xfrm>
           <a:prstGeom prst="rect">
             <a:avLst/>
@@ -8138,34 +8651,147 @@
             <a:noAutofit/>
           </a:bodyPr>
           <a:p>
-            <a:pPr indent="0" algn="ctr" defTabSz="457200">
-              <a:lnSpc>
-                <a:spcPct val="100000"/>
-              </a:lnSpc>
-              <a:spcBef>
-                <a:spcPts val="641"/>
-              </a:spcBef>
-              <a:buNone/>
-              <a:tabLst>
-                <a:tab pos="0" algn="l"/>
-              </a:tabLst>
-            </a:pPr>
-            <a:r>
-              <a:rPr lang="en-US" sz="3200" b="0" u="none" strike="noStrike">
-                <a:solidFill>
-                  <a:schemeClr val="dk1">
-                    <a:tint val="75000"/>
-                  </a:schemeClr>
-                </a:solidFill>
-                <a:effectLst/>
-                <a:uFillTx/>
-                <a:latin typeface="Calibri"/>
-              </a:rPr>
-              <a:t>Academic and Technical Journey</a:t>
-            </a:r>
-            <a:endParaRPr lang="en-US" sz="3200" b="0" u="none" strike="noStrike">
-              <a:solidFill>
-                <a:srgbClr val="000000"/>
+            <a:pPr marL="343080" indent="-343080" algn="l" defTabSz="457200">
+              <a:lnSpc>
+                <a:spcPct val="100000"/>
+              </a:lnSpc>
+              <a:spcBef>
+                <a:spcPts val="400"/>
+              </a:spcBef>
+              <a:spcAft>
+                <a:spcPts val="1400"/>
+              </a:spcAft>
+              <a:buClr>
+                <a:srgbClr val="1E293B"/>
+              </a:buClr>
+              <a:buFont typeface="Arial"/>
+              <a:buChar char="•"/>
+            </a:pPr>
+            <a:r>
+              <a:rPr lang="en-US" sz="2000" b="0" u="none" strike="noStrike">
+                <a:solidFill>
+                  <a:srgbClr val="1E293B"/>
+                </a:solidFill>
+                <a:effectLst/>
+                <a:uFillTx/>
+                <a:latin typeface="Calibri"/>
+              </a:rPr>
+              <a:t>Born on 25th May 2004 in Kitui County.</a:t>
+            </a:r>
+            <a:endParaRPr lang="en-US" sz="2000" b="0" u="none" strike="noStrike">
+              <a:solidFill>
+                <a:srgbClr val="009BDD"/>
+              </a:solidFill>
+              <a:effectLst/>
+              <a:uFillTx/>
+              <a:latin typeface="Times New Roman"/>
+            </a:endParaRPr>
+          </a:p>
+          <a:p>
+            <a:pPr marL="343080" indent="-343080" algn="l" defTabSz="457200">
+              <a:lnSpc>
+                <a:spcPct val="100000"/>
+              </a:lnSpc>
+              <a:spcBef>
+                <a:spcPts val="400"/>
+              </a:spcBef>
+              <a:spcAft>
+                <a:spcPts val="1400"/>
+              </a:spcAft>
+              <a:buClr>
+                <a:srgbClr val="1E293B"/>
+              </a:buClr>
+              <a:buFont typeface="Arial"/>
+              <a:buChar char="•"/>
+            </a:pPr>
+            <a:r>
+              <a:rPr lang="en-US" sz="2000" b="0" u="none" strike="noStrike">
+                <a:solidFill>
+                  <a:srgbClr val="1E293B"/>
+                </a:solidFill>
+                <a:effectLst/>
+                <a:uFillTx/>
+                <a:latin typeface="Calibri"/>
+              </a:rPr>
+              <a:t>Raised in a close-knit family anchored by the sacrifices of my father (a dedicated businessperson) and the warmth of my mother.</a:t>
+            </a:r>
+            <a:endParaRPr lang="en-US" sz="2000" b="0" u="none" strike="noStrike">
+              <a:solidFill>
+                <a:srgbClr val="009BDD"/>
+              </a:solidFill>
+              <a:effectLst/>
+              <a:uFillTx/>
+              <a:latin typeface="Times New Roman"/>
+            </a:endParaRPr>
+          </a:p>
+          <a:p>
+            <a:pPr marL="343080" indent="-343080" algn="l" defTabSz="457200">
+              <a:lnSpc>
+                <a:spcPct val="100000"/>
+              </a:lnSpc>
+              <a:spcBef>
+                <a:spcPts val="400"/>
+              </a:spcBef>
+              <a:spcAft>
+                <a:spcPts val="1400"/>
+              </a:spcAft>
+              <a:buClr>
+                <a:srgbClr val="1E293B"/>
+              </a:buClr>
+              <a:buFont typeface="Arial"/>
+              <a:buChar char="•"/>
+            </a:pPr>
+            <a:r>
+              <a:rPr lang="en-US" sz="2000" b="0" u="none" strike="noStrike">
+                <a:solidFill>
+                  <a:srgbClr val="1E293B"/>
+                </a:solidFill>
+                <a:effectLst/>
+                <a:uFillTx/>
+                <a:latin typeface="Calibri"/>
+              </a:rPr>
+              <a:t>Grew up in a blended/extended family alongside younger siblings Stephen Muli and Grace Musyoki.</a:t>
+            </a:r>
+            <a:endParaRPr lang="en-US" sz="2000" b="0" u="none" strike="noStrike">
+              <a:solidFill>
+                <a:srgbClr val="009BDD"/>
+              </a:solidFill>
+              <a:effectLst/>
+              <a:uFillTx/>
+              <a:latin typeface="Times New Roman"/>
+            </a:endParaRPr>
+          </a:p>
+          <a:p>
+            <a:pPr marL="343080" indent="-343080" algn="l" defTabSz="457200">
+              <a:lnSpc>
+                <a:spcPct val="100000"/>
+              </a:lnSpc>
+              <a:spcBef>
+                <a:spcPts val="400"/>
+              </a:spcBef>
+              <a:spcAft>
+                <a:spcPts val="1400"/>
+              </a:spcAft>
+              <a:buClr>
+                <a:srgbClr val="1E293B"/>
+              </a:buClr>
+              <a:buFont typeface="Arial"/>
+              <a:buChar char="•"/>
+            </a:pPr>
+            <a:r>
+              <a:rPr lang="en-US" sz="2000" b="0" u="none" strike="noStrike">
+                <a:solidFill>
+                  <a:srgbClr val="1E293B"/>
+                </a:solidFill>
+                <a:effectLst/>
+                <a:uFillTx/>
+                <a:latin typeface="Calibri"/>
+              </a:rPr>
+              <a:t>Learned early lessons of leadership, patience, and protection as the eldest brother.</a:t>
+            </a:r>
+            <a:endParaRPr lang="en-US" sz="2000" b="0" u="none" strike="noStrike">
+              <a:solidFill>
+                <a:srgbClr val="009BDD"/>
               </a:solidFill>
               <a:effectLst/>
               <a:uFillTx/>
@@ -8187,7 +8813,7 @@
 </p:sld>
 </file>
 
-<file path=ppt/slides/slide2.xml><?xml version="1.0" encoding="utf-8"?>
+<file path=ppt/slides/slide3.xml><?xml version="1.0" encoding="utf-8"?>
 <p:sld xmlns:a="http://schemas.openxmlformats.org/drawingml/2006/main" xmlns:p="http://schemas.openxmlformats.org/presentationml/2006/main" xmlns:r="http://schemas.openxmlformats.org/officeDocument/2006/relationships" xmlns:p14="http://schemas.microsoft.com/office/powerpoint/2010/main" xmlns:p15="http://schemas.microsoft.com/office/powerpoint/2012/main" xmlns:mc="http://schemas.openxmlformats.org/markup-compatibility/2006">
   <p:cSld>
     <p:spTree>
@@ -8239,19 +8865,19 @@
               <a:buNone/>
             </a:pPr>
             <a:r>
-              <a:rPr lang="en-US" sz="4400" b="0" u="none" strike="noStrike">
-                <a:solidFill>
-                  <a:schemeClr val="dk1"/>
-                </a:solidFill>
-                <a:effectLst/>
-                <a:uFillTx/>
-                <a:latin typeface="Calibri"/>
-              </a:rPr>
-              <a:t>Academic Foundation</a:t>
-            </a:r>
-            <a:endParaRPr lang="en-US" sz="4400" b="0" u="none" strike="noStrike">
-              <a:solidFill>
-                <a:srgbClr val="000000"/>
+              <a:rPr lang="en-US" sz="3200" b="1" u="none" strike="noStrike">
+                <a:solidFill>
+                  <a:srgbClr val="0F766E"/>
+                </a:solidFill>
+                <a:effectLst/>
+                <a:uFillTx/>
+                <a:latin typeface="Calibri"/>
+              </a:rPr>
+              <a:t>2. The Village Classroom: Lessons from Nature</a:t>
+            </a:r>
+            <a:endParaRPr lang="en-US" sz="3200" b="0" u="none" strike="noStrike">
+              <a:solidFill>
+                <a:srgbClr val="DD4100"/>
               </a:solidFill>
               <a:effectLst/>
               <a:uFillTx/>
@@ -8293,28 +8919,31 @@
                 <a:spcPct val="100000"/>
               </a:lnSpc>
               <a:spcBef>
-                <a:spcPts val="641"/>
-              </a:spcBef>
-              <a:buClr>
-                <a:srgbClr val="000000"/>
+                <a:spcPts val="400"/>
+              </a:spcBef>
+              <a:spcAft>
+                <a:spcPts val="1400"/>
+              </a:spcAft>
+              <a:buClr>
+                <a:srgbClr val="1E293B"/>
               </a:buClr>
               <a:buFont typeface="Arial"/>
               <a:buChar char="•"/>
             </a:pPr>
             <a:r>
-              <a:rPr lang="en-US" sz="3200" b="0" u="none" strike="noStrike">
-                <a:solidFill>
-                  <a:schemeClr val="dk1"/>
-                </a:solidFill>
-                <a:effectLst/>
-                <a:uFillTx/>
-                <a:latin typeface="Calibri"/>
-              </a:rPr>
-              <a:t>Maseno School, Kisumu</a:t>
-            </a:r>
-            <a:endParaRPr lang="en-US" sz="3200" b="0" u="none" strike="noStrike">
-              <a:solidFill>
-                <a:srgbClr val="000000"/>
+              <a:rPr lang="en-US" sz="2000" b="0" u="none" strike="noStrike">
+                <a:solidFill>
+                  <a:srgbClr val="1E293B"/>
+                </a:solidFill>
+                <a:effectLst/>
+                <a:uFillTx/>
+                <a:latin typeface="Calibri"/>
+              </a:rPr>
+              <a:t>Experienced the stark contrast between lush rainy seasons (maize and bean farming) and harsh dry seasons.</a:t>
+            </a:r>
+            <a:endParaRPr lang="en-US" sz="2000" b="0" u="none" strike="noStrike">
+              <a:solidFill>
+                <a:srgbClr val="009BDD"/>
               </a:solidFill>
               <a:effectLst/>
               <a:uFillTx/>
@@ -8327,28 +8956,31 @@
                 <a:spcPct val="100000"/>
               </a:lnSpc>
               <a:spcBef>
-                <a:spcPts val="641"/>
-              </a:spcBef>
-              <a:buClr>
-                <a:srgbClr val="000000"/>
+                <a:spcPts val="400"/>
+              </a:spcBef>
+              <a:spcAft>
+                <a:spcPts val="1400"/>
+              </a:spcAft>
+              <a:buClr>
+                <a:srgbClr val="1E293B"/>
               </a:buClr>
               <a:buFont typeface="Arial"/>
               <a:buChar char="•"/>
             </a:pPr>
             <a:r>
-              <a:rPr lang="en-US" sz="3200" b="0" u="none" strike="noStrike">
-                <a:solidFill>
-                  <a:schemeClr val="dk1"/>
-                </a:solidFill>
-                <a:effectLst/>
-                <a:uFillTx/>
-                <a:latin typeface="Calibri"/>
-              </a:rPr>
-              <a:t>2019-2022</a:t>
-            </a:r>
-            <a:endParaRPr lang="en-US" sz="3200" b="0" u="none" strike="noStrike">
-              <a:solidFill>
-                <a:srgbClr val="000000"/>
+              <a:rPr lang="en-US" sz="2000" b="0" u="none" strike="noStrike">
+                <a:solidFill>
+                  <a:srgbClr val="1E293B"/>
+                </a:solidFill>
+                <a:effectLst/>
+                <a:uFillTx/>
+                <a:latin typeface="Calibri"/>
+              </a:rPr>
+              <a:t>Daily routines built physical endurance: waking at dawn, fetching water from streams, collecting firewood, and herding goats.</a:t>
+            </a:r>
+            <a:endParaRPr lang="en-US" sz="2000" b="0" u="none" strike="noStrike">
+              <a:solidFill>
+                <a:srgbClr val="009BDD"/>
               </a:solidFill>
               <a:effectLst/>
               <a:uFillTx/>
@@ -8361,28 +8993,68 @@
                 <a:spcPct val="100000"/>
               </a:lnSpc>
               <a:spcBef>
-                <a:spcPts val="641"/>
-              </a:spcBef>
-              <a:buClr>
-                <a:srgbClr val="000000"/>
+                <a:spcPts val="400"/>
+              </a:spcBef>
+              <a:spcAft>
+                <a:spcPts val="1400"/>
+              </a:spcAft>
+              <a:buClr>
+                <a:srgbClr val="1E293B"/>
               </a:buClr>
               <a:buFont typeface="Arial"/>
               <a:buChar char="•"/>
             </a:pPr>
             <a:r>
-              <a:rPr lang="en-US" sz="3200" b="0" u="none" strike="noStrike">
-                <a:solidFill>
-                  <a:schemeClr val="dk1"/>
-                </a:solidFill>
-                <a:effectLst/>
-                <a:uFillTx/>
-                <a:latin typeface="Calibri"/>
-              </a:rPr>
-              <a:t>K.C.S.E Grade: B+</a:t>
-            </a:r>
-            <a:endParaRPr lang="en-US" sz="3200" b="0" u="none" strike="noStrike">
-              <a:solidFill>
-                <a:srgbClr val="000000"/>
+              <a:rPr lang="en-US" sz="2000" b="0" u="none" strike="noStrike">
+                <a:solidFill>
+                  <a:srgbClr val="1E293B"/>
+                </a:solidFill>
+                <a:effectLst/>
+                <a:uFillTx/>
+                <a:latin typeface="Calibri"/>
+              </a:rPr>
+              <a:t>Learned accountability through childhood mistakes (such as the goat-herding incident in a neighbor's farm).</a:t>
+            </a:r>
+            <a:endParaRPr lang="en-US" sz="2000" b="0" u="none" strike="noStrike">
+              <a:solidFill>
+                <a:srgbClr val="009BDD"/>
+              </a:solidFill>
+              <a:effectLst/>
+              <a:uFillTx/>
+              <a:latin typeface="Times New Roman"/>
+            </a:endParaRPr>
+          </a:p>
+          <a:p>
+            <a:pPr marL="343080" indent="-343080" algn="l" defTabSz="457200">
+              <a:lnSpc>
+                <a:spcPct val="100000"/>
+              </a:lnSpc>
+              <a:spcBef>
+                <a:spcPts val="400"/>
+              </a:spcBef>
+              <a:spcAft>
+                <a:spcPts val="1400"/>
+              </a:spcAft>
+              <a:buClr>
+                <a:srgbClr val="1E293B"/>
+              </a:buClr>
+              <a:buFont typeface="Arial"/>
+              <a:buChar char="•"/>
+            </a:pPr>
+            <a:r>
+              <a:rPr lang="en-US" sz="2000" b="0" u="none" strike="noStrike">
+                <a:solidFill>
+                  <a:srgbClr val="1E293B"/>
+                </a:solidFill>
+                <a:effectLst/>
+                <a:uFillTx/>
+                <a:latin typeface="Calibri"/>
+              </a:rPr>
+              <a:t>Core values forged: Perseverance, gratitude, and communal unity.</a:t>
+            </a:r>
+            <a:endParaRPr lang="en-US" sz="2000" b="0" u="none" strike="noStrike">
+              <a:solidFill>
+                <a:srgbClr val="009BDD"/>
               </a:solidFill>
               <a:effectLst/>
               <a:uFillTx/>
@@ -8404,7 +9076,7 @@
 </p:sld>
 </file>
 
-<file path=ppt/slides/slide3.xml><?xml version="1.0" encoding="utf-8"?>
+<file path=ppt/slides/slide4.xml><?xml version="1.0" encoding="utf-8"?>
 <p:sld xmlns:a="http://schemas.openxmlformats.org/drawingml/2006/main" xmlns:p="http://schemas.openxmlformats.org/presentationml/2006/main" xmlns:r="http://schemas.openxmlformats.org/officeDocument/2006/relationships" xmlns:p14="http://schemas.microsoft.com/office/powerpoint/2010/main" xmlns:p15="http://schemas.microsoft.com/office/powerpoint/2012/main" xmlns:mc="http://schemas.openxmlformats.org/markup-compatibility/2006">
   <p:cSld>
     <p:spTree>
@@ -8456,19 +9128,19 @@
               <a:buNone/>
             </a:pPr>
             <a:r>
-              <a:rPr lang="en-US" sz="4400" b="0" u="none" strike="noStrike">
-                <a:solidFill>
-                  <a:schemeClr val="dk1"/>
-                </a:solidFill>
-                <a:effectLst/>
-                <a:uFillTx/>
-                <a:latin typeface="Calibri"/>
-              </a:rPr>
-              <a:t>Higher Education</a:t>
-            </a:r>
-            <a:endParaRPr lang="en-US" sz="4400" b="0" u="none" strike="noStrike">
-              <a:solidFill>
-                <a:srgbClr val="000000"/>
+              <a:rPr lang="en-US" sz="3200" b="1" u="none" strike="noStrike">
+                <a:solidFill>
+                  <a:srgbClr val="0F766E"/>
+                </a:solidFill>
+                <a:effectLst/>
+                <a:uFillTx/>
+                <a:latin typeface="Calibri"/>
+              </a:rPr>
+              <a:t>3. Primary Education: St. Stephens Academy</a:t>
+            </a:r>
+            <a:endParaRPr lang="en-US" sz="3200" b="0" u="none" strike="noStrike">
+              <a:solidFill>
+                <a:srgbClr val="DD4100"/>
               </a:solidFill>
               <a:effectLst/>
               <a:uFillTx/>
@@ -8510,28 +9182,31 @@
                 <a:spcPct val="100000"/>
               </a:lnSpc>
               <a:spcBef>
-                <a:spcPts val="641"/>
-              </a:spcBef>
-              <a:buClr>
-                <a:srgbClr val="000000"/>
+                <a:spcPts val="400"/>
+              </a:spcBef>
+              <a:spcAft>
+                <a:spcPts val="1400"/>
+              </a:spcAft>
+              <a:buClr>
+                <a:srgbClr val="1E293B"/>
               </a:buClr>
               <a:buFont typeface="Arial"/>
               <a:buChar char="•"/>
             </a:pPr>
             <a:r>
-              <a:rPr lang="en-US" sz="3200" b="0" u="none" strike="noStrike">
-                <a:solidFill>
-                  <a:schemeClr val="dk1"/>
-                </a:solidFill>
-                <a:effectLst/>
-                <a:uFillTx/>
-                <a:latin typeface="Calibri"/>
-              </a:rPr>
-              <a:t>Dedan Kimathi University of Technology</a:t>
-            </a:r>
-            <a:endParaRPr lang="en-US" sz="3200" b="0" u="none" strike="noStrike">
-              <a:solidFill>
-                <a:srgbClr val="000000"/>
+              <a:rPr lang="en-US" sz="2000" b="0" u="none" strike="noStrike">
+                <a:solidFill>
+                  <a:srgbClr val="1E293B"/>
+                </a:solidFill>
+                <a:effectLst/>
+                <a:uFillTx/>
+                <a:latin typeface="Calibri"/>
+              </a:rPr>
+              <a:t>Attended St. Stephens Academy from baby class to Class Eight.</a:t>
+            </a:r>
+            <a:endParaRPr lang="en-US" sz="2000" b="0" u="none" strike="noStrike">
+              <a:solidFill>
+                <a:srgbClr val="009BDD"/>
               </a:solidFill>
               <a:effectLst/>
               <a:uFillTx/>
@@ -8544,28 +9219,31 @@
                 <a:spcPct val="100000"/>
               </a:lnSpc>
               <a:spcBef>
-                <a:spcPts val="641"/>
-              </a:spcBef>
-              <a:buClr>
-                <a:srgbClr val="000000"/>
+                <a:spcPts val="400"/>
+              </a:spcBef>
+              <a:spcAft>
+                <a:spcPts val="1400"/>
+              </a:spcAft>
+              <a:buClr>
+                <a:srgbClr val="1E293B"/>
               </a:buClr>
               <a:buFont typeface="Arial"/>
               <a:buChar char="•"/>
             </a:pPr>
             <a:r>
-              <a:rPr lang="en-US" sz="3200" b="0" u="none" strike="noStrike">
-                <a:solidFill>
-                  <a:schemeClr val="dk1"/>
-                </a:solidFill>
-                <a:effectLst/>
-                <a:uFillTx/>
-                <a:latin typeface="Calibri"/>
-              </a:rPr>
-              <a:t>Bachelor of Science in Information Technology</a:t>
-            </a:r>
-            <a:endParaRPr lang="en-US" sz="3200" b="0" u="none" strike="noStrike">
-              <a:solidFill>
-                <a:srgbClr val="000000"/>
+              <a:rPr lang="en-US" sz="2000" b="0" u="none" strike="noStrike">
+                <a:solidFill>
+                  <a:srgbClr val="1E293B"/>
+                </a:solidFill>
+                <a:effectLst/>
+                <a:uFillTx/>
+                <a:latin typeface="Calibri"/>
+              </a:rPr>
+              <a:t>Overcame daily physical hurdles walking up steep, muddy hills to reach the classroom.</a:t>
+            </a:r>
+            <a:endParaRPr lang="en-US" sz="2000" b="0" u="none" strike="noStrike">
+              <a:solidFill>
+                <a:srgbClr val="009BDD"/>
               </a:solidFill>
               <a:effectLst/>
               <a:uFillTx/>
@@ -8578,28 +9256,105 @@
                 <a:spcPct val="100000"/>
               </a:lnSpc>
               <a:spcBef>
-                <a:spcPts val="641"/>
-              </a:spcBef>
-              <a:buClr>
-                <a:srgbClr val="000000"/>
+                <a:spcPts val="400"/>
+              </a:spcBef>
+              <a:spcAft>
+                <a:spcPts val="1400"/>
+              </a:spcAft>
+              <a:buClr>
+                <a:srgbClr val="1E293B"/>
               </a:buClr>
               <a:buFont typeface="Arial"/>
               <a:buChar char="•"/>
             </a:pPr>
             <a:r>
-              <a:rPr lang="en-US" sz="3200" b="0" u="none" strike="noStrike">
-                <a:solidFill>
-                  <a:schemeClr val="dk1"/>
-                </a:solidFill>
-                <a:effectLst/>
-                <a:uFillTx/>
-                <a:latin typeface="Calibri"/>
-              </a:rPr>
-              <a:t>Current 45y Year Student</a:t>
-            </a:r>
-            <a:endParaRPr lang="en-US" sz="3200" b="0" u="none" strike="noStrike">
-              <a:solidFill>
-                <a:srgbClr val="000000"/>
+              <a:rPr lang="en-US" sz="2000" b="0" u="none" strike="noStrike">
+                <a:solidFill>
+                  <a:srgbClr val="1E293B"/>
+                </a:solidFill>
+                <a:effectLst/>
+                <a:uFillTx/>
+                <a:latin typeface="Calibri"/>
+              </a:rPr>
+              <a:t>Mentored by dedicated educators: Mr. Kivaa (Mathematics), Mr. Tom (Social Studies), Mr. Eric &amp; Mr. Paul (Science).</a:t>
+            </a:r>
+            <a:endParaRPr lang="en-US" sz="2000" b="0" u="none" strike="noStrike">
+              <a:solidFill>
+                <a:srgbClr val="009BDD"/>
+              </a:solidFill>
+              <a:effectLst/>
+              <a:uFillTx/>
+              <a:latin typeface="Times New Roman"/>
+            </a:endParaRPr>
+          </a:p>
+          <a:p>
+            <a:pPr marL="343080" indent="-343080" algn="l" defTabSz="457200">
+              <a:lnSpc>
+                <a:spcPct val="100000"/>
+              </a:lnSpc>
+              <a:spcBef>
+                <a:spcPts val="400"/>
+              </a:spcBef>
+              <a:spcAft>
+                <a:spcPts val="1400"/>
+              </a:spcAft>
+              <a:buClr>
+                <a:srgbClr val="1E293B"/>
+              </a:buClr>
+              <a:buFont typeface="Arial"/>
+              <a:buChar char="•"/>
+            </a:pPr>
+            <a:r>
+              <a:rPr lang="en-US" sz="2000" b="0" u="none" strike="noStrike">
+                <a:solidFill>
+                  <a:srgbClr val="1E293B"/>
+                </a:solidFill>
+                <a:effectLst/>
+                <a:uFillTx/>
+                <a:latin typeface="Calibri"/>
+              </a:rPr>
+              <a:t>Practiced childhood ingenuity on the playground using improvised plastic-bag footballs.</a:t>
+            </a:r>
+            <a:endParaRPr lang="en-US" sz="2000" b="0" u="none" strike="noStrike">
+              <a:solidFill>
+                <a:srgbClr val="009BDD"/>
+              </a:solidFill>
+              <a:effectLst/>
+              <a:uFillTx/>
+              <a:latin typeface="Times New Roman"/>
+            </a:endParaRPr>
+          </a:p>
+          <a:p>
+            <a:pPr marL="343080" indent="-343080" algn="l" defTabSz="457200">
+              <a:lnSpc>
+                <a:spcPct val="100000"/>
+              </a:lnSpc>
+              <a:spcBef>
+                <a:spcPts val="400"/>
+              </a:spcBef>
+              <a:spcAft>
+                <a:spcPts val="1400"/>
+              </a:spcAft>
+              <a:buClr>
+                <a:srgbClr val="1E293B"/>
+              </a:buClr>
+              <a:buFont typeface="Arial"/>
+              <a:buChar char="•"/>
+            </a:pPr>
+            <a:r>
+              <a:rPr lang="en-US" sz="2000" b="0" u="none" strike="noStrike">
+                <a:solidFill>
+                  <a:srgbClr val="1E293B"/>
+                </a:solidFill>
+                <a:effectLst/>
+                <a:uFillTx/>
+                <a:latin typeface="Calibri"/>
+              </a:rPr>
+              <a:t>Overcame early struggles in languages while excelling consistently in Mathematics and Science.</a:t>
+            </a:r>
+            <a:endParaRPr lang="en-US" sz="2000" b="0" u="none" strike="noStrike">
+              <a:solidFill>
+                <a:srgbClr val="009BDD"/>
               </a:solidFill>
               <a:effectLst/>
               <a:uFillTx/>
@@ -8621,7 +9376,7 @@
 </p:sld>
 </file>
 
-<file path=ppt/slides/slide4.xml><?xml version="1.0" encoding="utf-8"?>
+<file path=ppt/slides/slide5.xml><?xml version="1.0" encoding="utf-8"?>
 <p:sld xmlns:a="http://schemas.openxmlformats.org/drawingml/2006/main" xmlns:p="http://schemas.openxmlformats.org/presentationml/2006/main" xmlns:r="http://schemas.openxmlformats.org/officeDocument/2006/relationships" xmlns:p14="http://schemas.microsoft.com/office/powerpoint/2010/main" xmlns:p15="http://schemas.microsoft.com/office/powerpoint/2012/main" xmlns:mc="http://schemas.openxmlformats.org/markup-compatibility/2006">
   <p:cSld>
     <p:spTree>
@@ -8673,19 +9428,19 @@
               <a:buNone/>
             </a:pPr>
             <a:r>
-              <a:rPr lang="en-US" sz="4400" b="0" u="none" strike="noStrike">
-                <a:solidFill>
-                  <a:schemeClr val="dk1"/>
-                </a:solidFill>
-                <a:effectLst/>
-                <a:uFillTx/>
-                <a:latin typeface="Calibri"/>
-              </a:rPr>
-              <a:t>Core Competencies</a:t>
-            </a:r>
-            <a:endParaRPr lang="en-US" sz="4400" b="0" u="none" strike="noStrike">
-              <a:solidFill>
-                <a:srgbClr val="000000"/>
+              <a:rPr lang="en-US" sz="3200" b="1" u="none" strike="noStrike">
+                <a:solidFill>
+                  <a:srgbClr val="0F766E"/>
+                </a:solidFill>
+                <a:effectLst/>
+                <a:uFillTx/>
+                <a:latin typeface="Calibri"/>
+              </a:rPr>
+              <a:t>4. The Crucible of Maseno School (2019–2022)</a:t>
+            </a:r>
+            <a:endParaRPr lang="en-US" sz="3200" b="0" u="none" strike="noStrike">
+              <a:solidFill>
+                <a:srgbClr val="DD4100"/>
               </a:solidFill>
               <a:effectLst/>
               <a:uFillTx/>
@@ -8727,28 +9482,31 @@
                 <a:spcPct val="100000"/>
               </a:lnSpc>
               <a:spcBef>
-                <a:spcPts val="641"/>
-              </a:spcBef>
-              <a:buClr>
-                <a:srgbClr val="000000"/>
+                <a:spcPts val="400"/>
+              </a:spcBef>
+              <a:spcAft>
+                <a:spcPts val="1400"/>
+              </a:spcAft>
+              <a:buClr>
+                <a:srgbClr val="1E293B"/>
               </a:buClr>
               <a:buFont typeface="Arial"/>
               <a:buChar char="•"/>
             </a:pPr>
             <a:r>
-              <a:rPr lang="en-US" sz="3200" b="0" u="none" strike="noStrike">
-                <a:solidFill>
-                  <a:schemeClr val="dk1"/>
-                </a:solidFill>
-                <a:effectLst/>
-                <a:uFillTx/>
-                <a:latin typeface="Calibri"/>
-              </a:rPr>
-              <a:t>Programming: Python, Java, C++, JavaScript</a:t>
-            </a:r>
-            <a:endParaRPr lang="en-US" sz="3200" b="0" u="none" strike="noStrike">
-              <a:solidFill>
-                <a:srgbClr val="000000"/>
+              <a:rPr lang="en-US" sz="2000" b="0" u="none" strike="noStrike">
+                <a:solidFill>
+                  <a:srgbClr val="1E293B"/>
+                </a:solidFill>
+                <a:effectLst/>
+                <a:uFillTx/>
+                <a:latin typeface="Calibri"/>
+              </a:rPr>
+              <a:t>Transitioned to boarding life at Maseno School in Kisumu—adapting to crowded dormitories and strict dawn-to-night timetables.</a:t>
+            </a:r>
+            <a:endParaRPr lang="en-US" sz="2000" b="0" u="none" strike="noStrike">
+              <a:solidFill>
+                <a:srgbClr val="009BDD"/>
               </a:solidFill>
               <a:effectLst/>
               <a:uFillTx/>
@@ -8761,28 +9519,31 @@
                 <a:spcPct val="100000"/>
               </a:lnSpc>
               <a:spcBef>
-                <a:spcPts val="641"/>
-              </a:spcBef>
-              <a:buClr>
-                <a:srgbClr val="000000"/>
+                <a:spcPts val="400"/>
+              </a:spcBef>
+              <a:spcAft>
+                <a:spcPts val="1400"/>
+              </a:spcAft>
+              <a:buClr>
+                <a:srgbClr val="1E293B"/>
               </a:buClr>
               <a:buFont typeface="Arial"/>
               <a:buChar char="•"/>
             </a:pPr>
             <a:r>
-              <a:rPr lang="en-US" sz="3200" b="0" u="none" strike="noStrike">
-                <a:solidFill>
-                  <a:schemeClr val="dk1"/>
-                </a:solidFill>
-                <a:effectLst/>
-                <a:uFillTx/>
-                <a:latin typeface="Calibri"/>
-              </a:rPr>
-              <a:t>Web Development: HTML, CSS, React</a:t>
-            </a:r>
-            <a:endParaRPr lang="en-US" sz="3200" b="0" u="none" strike="noStrike">
-              <a:solidFill>
-                <a:srgbClr val="000000"/>
+              <a:rPr lang="en-US" sz="2000" b="0" u="none" strike="noStrike">
+                <a:solidFill>
+                  <a:srgbClr val="1E293B"/>
+                </a:solidFill>
+                <a:effectLst/>
+                <a:uFillTx/>
+                <a:latin typeface="Calibri"/>
+              </a:rPr>
+              <a:t>Overcame intense academic pressure in English and Kiswahili through consistent practice and teacher consultations.</a:t>
+            </a:r>
+            <a:endParaRPr lang="en-US" sz="2000" b="0" u="none" strike="noStrike">
+              <a:solidFill>
+                <a:srgbClr val="009BDD"/>
               </a:solidFill>
               <a:effectLst/>
               <a:uFillTx/>
@@ -8795,28 +9556,105 @@
                 <a:spcPct val="100000"/>
               </a:lnSpc>
               <a:spcBef>
-                <a:spcPts val="641"/>
-              </a:spcBef>
-              <a:buClr>
-                <a:srgbClr val="000000"/>
+                <a:spcPts val="400"/>
+              </a:spcBef>
+              <a:spcAft>
+                <a:spcPts val="1400"/>
+              </a:spcAft>
+              <a:buClr>
+                <a:srgbClr val="1E293B"/>
               </a:buClr>
               <a:buFont typeface="Arial"/>
               <a:buChar char="•"/>
             </a:pPr>
             <a:r>
-              <a:rPr lang="en-US" sz="3200" b="0" u="none" strike="noStrike">
-                <a:solidFill>
-                  <a:schemeClr val="dk1"/>
-                </a:solidFill>
-                <a:effectLst/>
-                <a:uFillTx/>
-                <a:latin typeface="Calibri"/>
-              </a:rPr>
-              <a:t>Database: MCisco Packet Tracer, Linux, Ubuntu</a:t>
-            </a:r>
-            <a:endParaRPr lang="en-US" sz="3200" b="0" u="none" strike="noStrike">
-              <a:solidFill>
-                <a:srgbClr val="000000"/>
+              <a:rPr lang="en-US" sz="2000" b="0" u="none" strike="noStrike">
+                <a:solidFill>
+                  <a:srgbClr val="1E293B"/>
+                </a:solidFill>
+                <a:effectLst/>
+                <a:uFillTx/>
+                <a:latin typeface="Calibri"/>
+              </a:rPr>
+              <a:t>Inspired by Mrs. Musango (Computer Studies), discovering technology as a tool to shape the future.</a:t>
+            </a:r>
+            <a:endParaRPr lang="en-US" sz="2000" b="0" u="none" strike="noStrike">
+              <a:solidFill>
+                <a:srgbClr val="009BDD"/>
+              </a:solidFill>
+              <a:effectLst/>
+              <a:uFillTx/>
+              <a:latin typeface="Times New Roman"/>
+            </a:endParaRPr>
+          </a:p>
+          <a:p>
+            <a:pPr marL="343080" indent="-343080" algn="l" defTabSz="457200">
+              <a:lnSpc>
+                <a:spcPct val="100000"/>
+              </a:lnSpc>
+              <a:spcBef>
+                <a:spcPts val="400"/>
+              </a:spcBef>
+              <a:spcAft>
+                <a:spcPts val="1400"/>
+              </a:spcAft>
+              <a:buClr>
+                <a:srgbClr val="1E293B"/>
+              </a:buClr>
+              <a:buFont typeface="Arial"/>
+              <a:buChar char="•"/>
+            </a:pPr>
+            <a:r>
+              <a:rPr lang="en-US" sz="2000" b="0" u="none" strike="noStrike">
+                <a:solidFill>
+                  <a:srgbClr val="1E293B"/>
+                </a:solidFill>
+                <a:effectLst/>
+                <a:uFillTx/>
+                <a:latin typeface="Calibri"/>
+              </a:rPr>
+              <a:t>Awarded Best Student in Mathematics (Forms 2 &amp; 3) and Top Student in Computer Studies (Forms 3 &amp; 4).</a:t>
+            </a:r>
+            <a:endParaRPr lang="en-US" sz="2000" b="0" u="none" strike="noStrike">
+              <a:solidFill>
+                <a:srgbClr val="009BDD"/>
+              </a:solidFill>
+              <a:effectLst/>
+              <a:uFillTx/>
+              <a:latin typeface="Times New Roman"/>
+            </a:endParaRPr>
+          </a:p>
+          <a:p>
+            <a:pPr marL="343080" indent="-343080" algn="l" defTabSz="457200">
+              <a:lnSpc>
+                <a:spcPct val="100000"/>
+              </a:lnSpc>
+              <a:spcBef>
+                <a:spcPts val="400"/>
+              </a:spcBef>
+              <a:spcAft>
+                <a:spcPts val="1400"/>
+              </a:spcAft>
+              <a:buClr>
+                <a:srgbClr val="1E293B"/>
+              </a:buClr>
+              <a:buFont typeface="Arial"/>
+              <a:buChar char="•"/>
+            </a:pPr>
+            <a:r>
+              <a:rPr lang="en-US" sz="2000" b="0" u="none" strike="noStrike">
+                <a:solidFill>
+                  <a:srgbClr val="1E293B"/>
+                </a:solidFill>
+                <a:effectLst/>
+                <a:uFillTx/>
+                <a:latin typeface="Calibri"/>
+              </a:rPr>
+              <a:t>Served as Class Prefect and Computer Laboratory Prefect, graduating with a strong KCSE grade.</a:t>
+            </a:r>
+            <a:endParaRPr lang="en-US" sz="2000" b="0" u="none" strike="noStrike">
+              <a:solidFill>
+                <a:srgbClr val="009BDD"/>
               </a:solidFill>
               <a:effectLst/>
               <a:uFillTx/>
@@ -8838,7 +9676,7 @@
 </p:sld>
 </file>
 
-<file path=ppt/slides/slide5.xml><?xml version="1.0" encoding="utf-8"?>
+<file path=ppt/slides/slide6.xml><?xml version="1.0" encoding="utf-8"?>
 <p:sld xmlns:a="http://schemas.openxmlformats.org/drawingml/2006/main" xmlns:p="http://schemas.openxmlformats.org/presentationml/2006/main" xmlns:r="http://schemas.openxmlformats.org/officeDocument/2006/relationships" xmlns:p14="http://schemas.microsoft.com/office/powerpoint/2010/main" xmlns:p15="http://schemas.microsoft.com/office/powerpoint/2012/main" xmlns:mc="http://schemas.openxmlformats.org/markup-compatibility/2006">
   <p:cSld>
     <p:spTree>
@@ -8890,19 +9728,19 @@
               <a:buNone/>
             </a:pPr>
             <a:r>
-              <a:rPr lang="en-US" sz="4400" b="0" u="none" strike="noStrike">
-                <a:solidFill>
-                  <a:schemeClr val="dk1"/>
-                </a:solidFill>
-                <a:effectLst/>
-                <a:uFillTx/>
-                <a:latin typeface="Calibri"/>
-              </a:rPr>
-              <a:t>Professional Certifications</a:t>
-            </a:r>
-            <a:endParaRPr lang="en-US" sz="4400" b="0" u="none" strike="noStrike">
-              <a:solidFill>
-                <a:srgbClr val="000000"/>
+              <a:rPr lang="en-US" sz="3200" b="1" u="none" strike="noStrike">
+                <a:solidFill>
+                  <a:srgbClr val="0F766E"/>
+                </a:solidFill>
+                <a:effectLst/>
+                <a:uFillTx/>
+                <a:latin typeface="Calibri"/>
+              </a:rPr>
+              <a:t>5. University Awakening at DeKUT</a:t>
+            </a:r>
+            <a:endParaRPr lang="en-US" sz="3200" b="0" u="none" strike="noStrike">
+              <a:solidFill>
+                <a:srgbClr val="DD4100"/>
               </a:solidFill>
               <a:effectLst/>
               <a:uFillTx/>
@@ -8944,28 +9782,31 @@
                 <a:spcPct val="100000"/>
               </a:lnSpc>
               <a:spcBef>
-                <a:spcPts val="641"/>
-              </a:spcBef>
-              <a:buClr>
-                <a:srgbClr val="000000"/>
+                <a:spcPts val="400"/>
+              </a:spcBef>
+              <a:spcAft>
+                <a:spcPts val="1400"/>
+              </a:spcAft>
+              <a:buClr>
+                <a:srgbClr val="1E293B"/>
               </a:buClr>
               <a:buFont typeface="Arial"/>
               <a:buChar char="•"/>
             </a:pPr>
             <a:r>
-              <a:rPr lang="en-US" sz="3200" b="0" u="none" strike="noStrike">
-                <a:solidFill>
-                  <a:schemeClr val="dk1"/>
-                </a:solidFill>
-                <a:effectLst/>
-                <a:uFillTx/>
-                <a:latin typeface="Calibri"/>
-              </a:rPr>
-              <a:t>Cisco Cybersecurity</a:t>
-            </a:r>
-            <a:endParaRPr lang="en-US" sz="3200" b="0" u="none" strike="noStrike">
-              <a:solidFill>
-                <a:srgbClr val="000000"/>
+              <a:rPr lang="en-US" sz="2000" b="0" u="none" strike="noStrike">
+                <a:solidFill>
+                  <a:srgbClr val="1E293B"/>
+                </a:solidFill>
+                <a:effectLst/>
+                <a:uFillTx/>
+                <a:latin typeface="Calibri"/>
+              </a:rPr>
+              <a:t>Enrolled in BSc Information Technology at Dedan Kimathi University of Technology (DeKUT), Nyeri.</a:t>
+            </a:r>
+            <a:endParaRPr lang="en-US" sz="2000" b="0" u="none" strike="noStrike">
+              <a:solidFill>
+                <a:srgbClr val="009BDD"/>
               </a:solidFill>
               <a:effectLst/>
               <a:uFillTx/>
@@ -8978,28 +9819,31 @@
                 <a:spcPct val="100000"/>
               </a:lnSpc>
               <a:spcBef>
-                <a:spcPts val="641"/>
-              </a:spcBef>
-              <a:buClr>
-                <a:srgbClr val="000000"/>
+                <a:spcPts val="400"/>
+              </a:spcBef>
+              <a:spcAft>
+                <a:spcPts val="1400"/>
+              </a:spcAft>
+              <a:buClr>
+                <a:srgbClr val="1E293B"/>
               </a:buClr>
               <a:buFont typeface="Arial"/>
               <a:buChar char="•"/>
             </a:pPr>
             <a:r>
-              <a:rPr lang="en-US" sz="3200" b="0" u="none" strike="noStrike">
-                <a:solidFill>
-                  <a:schemeClr val="dk1"/>
-                </a:solidFill>
-                <a:effectLst/>
-                <a:uFillTx/>
-                <a:latin typeface="Calibri"/>
-              </a:rPr>
-              <a:t>Cisco Linux Essentials</a:t>
-            </a:r>
-            <a:endParaRPr lang="en-US" sz="3200" b="0" u="none" strike="noStrike">
-              <a:solidFill>
-                <a:srgbClr val="000000"/>
+              <a:rPr lang="en-US" sz="2000" b="0" u="none" strike="noStrike">
+                <a:solidFill>
+                  <a:srgbClr val="1E293B"/>
+                </a:solidFill>
+                <a:effectLst/>
+                <a:uFillTx/>
+                <a:latin typeface="Calibri"/>
+              </a:rPr>
+              <a:t>Navigated the transition from strict high school supervision to managing personal freedom at Laduvet Hostels.</a:t>
+            </a:r>
+            <a:endParaRPr lang="en-US" sz="2000" b="0" u="none" strike="noStrike">
+              <a:solidFill>
+                <a:srgbClr val="009BDD"/>
               </a:solidFill>
               <a:effectLst/>
               <a:uFillTx/>
@@ -9012,28 +9856,68 @@
                 <a:spcPct val="100000"/>
               </a:lnSpc>
               <a:spcBef>
-                <a:spcPts val="641"/>
-              </a:spcBef>
-              <a:buClr>
-                <a:srgbClr val="000000"/>
+                <a:spcPts val="400"/>
+              </a:spcBef>
+              <a:spcAft>
+                <a:spcPts val="1400"/>
+              </a:spcAft>
+              <a:buClr>
+                <a:srgbClr val="1E293B"/>
               </a:buClr>
               <a:buFont typeface="Arial"/>
               <a:buChar char="•"/>
             </a:pPr>
             <a:r>
-              <a:rPr lang="en-US" sz="3200" b="0" u="none" strike="noStrike">
-                <a:solidFill>
-                  <a:schemeClr val="dk1"/>
-                </a:solidFill>
-                <a:effectLst/>
-                <a:uFillTx/>
-                <a:latin typeface="Calibri"/>
-              </a:rPr>
-              <a:t>Cisco Network Communication Basics</a:t>
-            </a:r>
-            <a:endParaRPr lang="en-US" sz="3200" b="0" u="none" strike="noStrike">
-              <a:solidFill>
-                <a:srgbClr val="000000"/>
+              <a:rPr lang="en-US" sz="2000" b="0" u="none" strike="noStrike">
+                <a:solidFill>
+                  <a:srgbClr val="1E293B"/>
+                </a:solidFill>
+                <a:effectLst/>
+                <a:uFillTx/>
+                <a:latin typeface="Calibri"/>
+              </a:rPr>
+              <a:t>Mastered core programming and infrastructure: Python, Java, C++, JavaScript, React, MySQL, and Linux.</a:t>
+            </a:r>
+            <a:endParaRPr lang="en-US" sz="2000" b="0" u="none" strike="noStrike">
+              <a:solidFill>
+                <a:srgbClr val="009BDD"/>
+              </a:solidFill>
+              <a:effectLst/>
+              <a:uFillTx/>
+              <a:latin typeface="Times New Roman"/>
+            </a:endParaRPr>
+          </a:p>
+          <a:p>
+            <a:pPr marL="343080" indent="-343080" algn="l" defTabSz="457200">
+              <a:lnSpc>
+                <a:spcPct val="100000"/>
+              </a:lnSpc>
+              <a:spcBef>
+                <a:spcPts val="400"/>
+              </a:spcBef>
+              <a:spcAft>
+                <a:spcPts val="1400"/>
+              </a:spcAft>
+              <a:buClr>
+                <a:srgbClr val="1E293B"/>
+              </a:buClr>
+              <a:buFont typeface="Arial"/>
+              <a:buChar char="•"/>
+            </a:pPr>
+            <a:r>
+              <a:rPr lang="en-US" sz="2000" b="0" u="none" strike="noStrike">
+                <a:solidFill>
+                  <a:srgbClr val="1E293B"/>
+                </a:solidFill>
+                <a:effectLst/>
+                <a:uFillTx/>
+                <a:latin typeface="Calibri"/>
+              </a:rPr>
+              <a:t>Earned industry certifications: Cisco Linux Essentials, Network Communication Basics, OS Basics, and Cybersecurity.</a:t>
+            </a:r>
+            <a:endParaRPr lang="en-US" sz="2000" b="0" u="none" strike="noStrike">
+              <a:solidFill>
+                <a:srgbClr val="009BDD"/>
               </a:solidFill>
               <a:effectLst/>
               <a:uFillTx/>
@@ -9055,7 +9939,7 @@
 </p:sld>
 </file>
 
-<file path=ppt/slides/slide6.xml><?xml version="1.0" encoding="utf-8"?>
+<file path=ppt/slides/slide7.xml><?xml version="1.0" encoding="utf-8"?>
 <p:sld xmlns:a="http://schemas.openxmlformats.org/drawingml/2006/main" xmlns:p="http://schemas.openxmlformats.org/presentationml/2006/main" xmlns:r="http://schemas.openxmlformats.org/officeDocument/2006/relationships" xmlns:p14="http://schemas.microsoft.com/office/powerpoint/2010/main" xmlns:p15="http://schemas.microsoft.com/office/powerpoint/2012/main" xmlns:mc="http://schemas.openxmlformats.org/markup-compatibility/2006">
   <p:cSld>
     <p:spTree>
@@ -9107,19 +9991,19 @@
               <a:buNone/>
             </a:pPr>
             <a:r>
-              <a:rPr lang="en-US" sz="4400" b="0" u="none" strike="noStrike">
-                <a:solidFill>
-                  <a:schemeClr val="dk1"/>
-                </a:solidFill>
-                <a:effectLst/>
-                <a:uFillTx/>
-                <a:latin typeface="Calibri"/>
-              </a:rPr>
-              <a:t>Key Projects</a:t>
-            </a:r>
-            <a:endParaRPr lang="en-US" sz="4400" b="0" u="none" strike="noStrike">
-              <a:solidFill>
-                <a:srgbClr val="000000"/>
+              <a:rPr lang="en-US" sz="3200" b="1" u="none" strike="noStrike">
+                <a:solidFill>
+                  <a:srgbClr val="0F766E"/>
+                </a:solidFill>
+                <a:effectLst/>
+                <a:uFillTx/>
+                <a:latin typeface="Calibri"/>
+              </a:rPr>
+              <a:t>6. Faith, Fellowship &amp; Personal Transformation</a:t>
+            </a:r>
+            <a:endParaRPr lang="en-US" sz="3200" b="0" u="none" strike="noStrike">
+              <a:solidFill>
+                <a:srgbClr val="DD4100"/>
               </a:solidFill>
               <a:effectLst/>
               <a:uFillTx/>
@@ -9161,62 +10045,294 @@
                 <a:spcPct val="100000"/>
               </a:lnSpc>
               <a:spcBef>
-                <a:spcPts val="641"/>
-              </a:spcBef>
-              <a:buClr>
-                <a:srgbClr val="000000"/>
+                <a:spcPts val="400"/>
+              </a:spcBef>
+              <a:spcAft>
+                <a:spcPts val="1400"/>
+              </a:spcAft>
+              <a:buClr>
+                <a:srgbClr val="1E293B"/>
               </a:buClr>
               <a:buFont typeface="Arial"/>
               <a:buChar char="•"/>
             </a:pPr>
             <a:r>
-              <a:rPr lang="en-US" sz="3200" b="0" u="none" strike="noStrike">
-                <a:solidFill>
-                  <a:schemeClr val="dk1"/>
-                </a:solidFill>
-                <a:effectLst/>
-                <a:uFillTx/>
-                <a:latin typeface="Calibri"/>
-              </a:rPr>
-              <a:t>Waste Management System (React, JS, HTML, CSS)</a:t>
+              <a:rPr lang="en-US" sz="2000" b="0" u="none" strike="noStrike">
+                <a:solidFill>
+                  <a:srgbClr val="1E293B"/>
+                </a:solidFill>
+                <a:effectLst/>
+                <a:uFillTx/>
+                <a:latin typeface="Calibri"/>
+              </a:rPr>
+              <a:t>Anchored by Catholic faith: Baptized as Benedict (Class 4) and Confirmed (Class 6) at St. Patrick Catholic Church.</a:t>
+            </a:r>
+            <a:endParaRPr lang="en-US" sz="2000" b="0" u="none" strike="noStrike">
+              <a:solidFill>
+                <a:srgbClr val="009BDD"/>
+              </a:solidFill>
+              <a:effectLst/>
+              <a:uFillTx/>
+              <a:latin typeface="Times New Roman"/>
+            </a:endParaRPr>
+          </a:p>
+          <a:p>
+            <a:pPr marL="343080" indent="-343080" algn="l" defTabSz="457200">
+              <a:lnSpc>
+                <a:spcPct val="100000"/>
+              </a:lnSpc>
+              <a:spcBef>
+                <a:spcPts val="400"/>
+              </a:spcBef>
+              <a:spcAft>
+                <a:spcPts val="1400"/>
+              </a:spcAft>
+              <a:buClr>
+                <a:srgbClr val="1E293B"/>
+              </a:buClr>
+              <a:buFont typeface="Arial"/>
+              <a:buChar char="•"/>
+            </a:pPr>
+            <a:r>
+              <a:rPr lang="en-US" sz="2000" b="0" u="none" strike="noStrike">
+                <a:solidFill>
+                  <a:srgbClr val="1E293B"/>
+                </a:solidFill>
+                <a:effectLst/>
+                <a:uFillTx/>
+                <a:latin typeface="Calibri"/>
+              </a:rPr>
+              <a:t>Served as Vice Chairperson and later Secretary of the DeKUT Catholic Association Altar Servers Group.</a:t>
+            </a:r>
+            <a:endParaRPr lang="en-US" sz="2000" b="0" u="none" strike="noStrike">
+              <a:solidFill>
+                <a:srgbClr val="009BDD"/>
+              </a:solidFill>
+              <a:effectLst/>
+              <a:uFillTx/>
+              <a:latin typeface="Times New Roman"/>
+            </a:endParaRPr>
+          </a:p>
+          <a:p>
+            <a:pPr marL="343080" indent="-343080" algn="l" defTabSz="457200">
+              <a:lnSpc>
+                <a:spcPct val="100000"/>
+              </a:lnSpc>
+              <a:spcBef>
+                <a:spcPts val="400"/>
+              </a:spcBef>
+              <a:spcAft>
+                <a:spcPts val="1400"/>
+              </a:spcAft>
+              <a:buClr>
+                <a:srgbClr val="1E293B"/>
+              </a:buClr>
+              <a:buFont typeface="Arial"/>
+              <a:buChar char="•"/>
+            </a:pPr>
+            <a:r>
+              <a:rPr lang="en-US" sz="2000" b="0" u="none" strike="noStrike">
+                <a:solidFill>
+                  <a:srgbClr val="1E293B"/>
+                </a:solidFill>
+                <a:effectLst/>
+                <a:uFillTx/>
+                <a:latin typeface="Calibri"/>
+              </a:rPr>
+              <a:t>Active member of St. Thomas Aquinas Bible Study, St. Angelus Group, and the Data Science &amp; AI Club (DSAIC).</a:t>
+            </a:r>
+            <a:endParaRPr lang="en-US" sz="2000" b="0" u="none" strike="noStrike">
+              <a:solidFill>
+                <a:srgbClr val="009BDD"/>
+              </a:solidFill>
+              <a:effectLst/>
+              <a:uFillTx/>
+              <a:latin typeface="Times New Roman"/>
+            </a:endParaRPr>
+          </a:p>
+          <a:p>
+            <a:pPr marL="343080" indent="-343080" algn="l" defTabSz="457200">
+              <a:lnSpc>
+                <a:spcPct val="100000"/>
+              </a:lnSpc>
+              <a:spcBef>
+                <a:spcPts val="400"/>
+              </a:spcBef>
+              <a:spcAft>
+                <a:spcPts val="1400"/>
+              </a:spcAft>
+              <a:buClr>
+                <a:srgbClr val="1E293B"/>
+              </a:buClr>
+              <a:buFont typeface="Arial"/>
+              <a:buChar char="•"/>
+            </a:pPr>
+            <a:r>
+              <a:rPr lang="en-US" sz="2000" b="0" u="none" strike="noStrike">
+                <a:solidFill>
+                  <a:srgbClr val="1E293B"/>
+                </a:solidFill>
+                <a:effectLst/>
+                <a:uFillTx/>
+                <a:latin typeface="Calibri"/>
+              </a:rPr>
+              <a:t>Overcame childhood introversion through campus hackathons, community outreach at children's homes, and hiking at Karima Forest.</a:t>
+            </a:r>
+            <a:endParaRPr lang="en-US" sz="2000" b="0" u="none" strike="noStrike">
+              <a:solidFill>
+                <a:srgbClr val="009BDD"/>
+              </a:solidFill>
+              <a:effectLst/>
+              <a:uFillTx/>
+              <a:latin typeface="Times New Roman"/>
+            </a:endParaRPr>
+          </a:p>
+        </p:txBody>
+      </p:sp>
+    </p:spTree>
+  </p:cSld>
+  <mc:AlternateContent>
+    <mc:Choice Requires="p14">
+      <p:transition spd="slow" p14:dur="2000"/>
+    </mc:Choice>
+    <mc:Fallback>
+      <p:transition spd="slow"/>
+    </mc:Fallback>
+  </mc:AlternateContent>
+</p:sld>
+</file>
+
+<file path=ppt/slides/slide8.xml><?xml version="1.0" encoding="utf-8"?>
+<p:sld xmlns:a="http://schemas.openxmlformats.org/drawingml/2006/main" xmlns:p="http://schemas.openxmlformats.org/presentationml/2006/main" xmlns:r="http://schemas.openxmlformats.org/officeDocument/2006/relationships" xmlns:p14="http://schemas.microsoft.com/office/powerpoint/2010/main" xmlns:p15="http://schemas.microsoft.com/office/powerpoint/2012/main" xmlns:mc="http://schemas.openxmlformats.org/markup-compatibility/2006">
+  <p:cSld>
+    <p:spTree>
+      <p:nvGrpSpPr>
+        <p:cNvPr id="1" name=""/>
+        <p:cNvGrpSpPr/>
+        <p:nvPr/>
+      </p:nvGrpSpPr>
+      <p:grpSpPr>
+        <a:xfrm>
+          <a:off x="0" y="0"/>
+          <a:ext cx="0" cy="0"/>
+          <a:chOff x="0" y="0"/>
+          <a:chExt cx="0" cy="0"/>
+        </a:xfrm>
+      </p:grpSpPr>
+      <p:sp>
+        <p:nvSpPr>
+          <p:cNvPr id="84" name="PlaceHolder 1"/>
+          <p:cNvSpPr>
+            <a:spLocks noGrp="1"/>
+          </p:cNvSpPr>
+          <p:nvPr>
+            <p:ph type="title"/>
+          </p:nvPr>
+        </p:nvSpPr>
+        <p:spPr>
+          <a:xfrm>
+            <a:off x="457200" y="274680"/>
+            <a:ext cx="8229240" cy="1142640"/>
+          </a:xfrm>
+          <a:prstGeom prst="rect">
+            <a:avLst/>
+          </a:prstGeom>
+          <a:noFill/>
+          <a:ln w="0">
+            <a:noFill/>
+          </a:ln>
+        </p:spPr>
+        <p:txBody>
+          <a:bodyPr lIns="91440" tIns="45720" rIns="91440" bIns="45720" anchor="ctr">
+            <a:noAutofit/>
+          </a:bodyPr>
+          <a:p>
+            <a:pPr indent="0" algn="ctr" defTabSz="457200">
+              <a:lnSpc>
+                <a:spcPct val="100000"/>
+              </a:lnSpc>
+              <a:buNone/>
+            </a:pPr>
+            <a:r>
+              <a:rPr lang="en-US" sz="3200" b="1" u="none" strike="noStrike">
+                <a:solidFill>
+                  <a:srgbClr val="0F766E"/>
+                </a:solidFill>
+                <a:effectLst/>
+                <a:uFillTx/>
+                <a:latin typeface="Calibri"/>
+              </a:rPr>
+              <a:t>7. Career Vision &amp; Life Philosophy</a:t>
             </a:r>
             <a:endParaRPr lang="en-US" sz="3200" b="0" u="none" strike="noStrike">
               <a:solidFill>
-                <a:srgbClr val="000000"/>
+                <a:srgbClr val="DD4100"/>
               </a:solidFill>
               <a:effectLst/>
               <a:uFillTx/>
               <a:latin typeface="Times New Roman"/>
             </a:endParaRPr>
           </a:p>
+        </p:txBody>
+      </p:sp>
+      <p:sp>
+        <p:nvSpPr>
+          <p:cNvPr id="85" name="PlaceHolder 2"/>
+          <p:cNvSpPr>
+            <a:spLocks noGrp="1"/>
+          </p:cNvSpPr>
+          <p:nvPr>
+            <p:ph/>
+          </p:nvPr>
+        </p:nvSpPr>
+        <p:spPr>
+          <a:xfrm>
+            <a:off x="457200" y="1600200"/>
+            <a:ext cx="8229240" cy="4525560"/>
+          </a:xfrm>
+          <a:prstGeom prst="rect">
+            <a:avLst/>
+          </a:prstGeom>
+          <a:noFill/>
+          <a:ln w="0">
+            <a:noFill/>
+          </a:ln>
+        </p:spPr>
+        <p:txBody>
+          <a:bodyPr lIns="91440" tIns="45720" rIns="91440" bIns="45720" anchor="t">
+            <a:noAutofit/>
+          </a:bodyPr>
           <a:p>
             <a:pPr marL="343080" indent="-343080" algn="l" defTabSz="457200">
               <a:lnSpc>
                 <a:spcPct val="100000"/>
               </a:lnSpc>
               <a:spcBef>
-                <a:spcPts val="641"/>
-              </a:spcBef>
-              <a:buClr>
-                <a:srgbClr val="000000"/>
+                <a:spcPts val="400"/>
+              </a:spcBef>
+              <a:spcAft>
+                <a:spcPts val="1400"/>
+              </a:spcAft>
+              <a:buClr>
+                <a:srgbClr val="1E293B"/>
               </a:buClr>
               <a:buFont typeface="Arial"/>
               <a:buChar char="•"/>
             </a:pPr>
             <a:r>
-              <a:rPr lang="en-US" sz="3200" b="0" u="none" strike="noStrike">
-                <a:solidFill>
-                  <a:schemeClr val="dk1"/>
-                </a:solidFill>
-                <a:effectLst/>
-                <a:uFillTx/>
-                <a:latin typeface="Calibri"/>
-              </a:rPr>
-              <a:t>Personal Portfolio (TSP Solver integration)</a:t>
-            </a:r>
-            <a:endParaRPr lang="en-US" sz="3200" b="0" u="none" strike="noStrike">
-              <a:solidFill>
-                <a:srgbClr val="000000"/>
+              <a:rPr lang="en-US" sz="2000" b="0" u="none" strike="noStrike">
+                <a:solidFill>
+                  <a:srgbClr val="1E293B"/>
+                </a:solidFill>
+                <a:effectLst/>
+                <a:uFillTx/>
+                <a:latin typeface="Calibri"/>
+              </a:rPr>
+              <a:t>Short-Term Goal: Secure an industrial attachment/engineering role in Software Development, Networking, or Cybersecurity.</a:t>
+            </a:r>
+            <a:endParaRPr lang="en-US" sz="2000" b="0" u="none" strike="noStrike">
+              <a:solidFill>
+                <a:srgbClr val="009BDD"/>
               </a:solidFill>
               <a:effectLst/>
               <a:uFillTx/>
@@ -9229,28 +10345,105 @@
                 <a:spcPct val="100000"/>
               </a:lnSpc>
               <a:spcBef>
-                <a:spcPts val="641"/>
-              </a:spcBef>
-              <a:buClr>
-                <a:srgbClr val="000000"/>
+                <a:spcPts val="400"/>
+              </a:spcBef>
+              <a:spcAft>
+                <a:spcPts val="1400"/>
+              </a:spcAft>
+              <a:buClr>
+                <a:srgbClr val="1E293B"/>
               </a:buClr>
               <a:buFont typeface="Arial"/>
               <a:buChar char="•"/>
             </a:pPr>
             <a:r>
-              <a:rPr lang="en-US" sz="3200" b="0" u="none" strike="noStrike">
-                <a:solidFill>
-                  <a:schemeClr val="dk1"/>
-                </a:solidFill>
-                <a:effectLst/>
-                <a:uFillTx/>
-                <a:latin typeface="Calibri"/>
-              </a:rPr>
-              <a:t>Collaborative teamwork and documentation focus</a:t>
-            </a:r>
-            <a:endParaRPr lang="en-US" sz="3200" b="0" u="none" strike="noStrike">
-              <a:solidFill>
-                <a:srgbClr val="000000"/>
+              <a:rPr lang="en-US" sz="2000" b="0" u="none" strike="noStrike">
+                <a:solidFill>
+                  <a:srgbClr val="1E293B"/>
+                </a:solidFill>
+                <a:effectLst/>
+                <a:uFillTx/>
+                <a:latin typeface="Calibri"/>
+              </a:rPr>
+              <a:t>Long-Term Goal (5–10 Years): Establish an elite IT company and consultancy to create youth employment in Kenya.</a:t>
+            </a:r>
+            <a:endParaRPr lang="en-US" sz="2000" b="0" u="none" strike="noStrike">
+              <a:solidFill>
+                <a:srgbClr val="009BDD"/>
+              </a:solidFill>
+              <a:effectLst/>
+              <a:uFillTx/>
+              <a:latin typeface="Times New Roman"/>
+            </a:endParaRPr>
+          </a:p>
+          <a:p>
+            <a:pPr marL="343080" indent="-343080" algn="l" defTabSz="457200">
+              <a:lnSpc>
+                <a:spcPct val="100000"/>
+              </a:lnSpc>
+              <a:spcBef>
+                <a:spcPts val="400"/>
+              </a:spcBef>
+              <a:spcAft>
+                <a:spcPts val="1400"/>
+              </a:spcAft>
+              <a:buClr>
+                <a:srgbClr val="1E293B"/>
+              </a:buClr>
+              <a:buFont typeface="Arial"/>
+              <a:buChar char="•"/>
+            </a:pPr>
+            <a:r>
+              <a:rPr lang="en-US" sz="2000" b="0" u="none" strike="noStrike">
+                <a:solidFill>
+                  <a:srgbClr val="1E293B"/>
+                </a:solidFill>
+                <a:effectLst/>
+                <a:uFillTx/>
+                <a:latin typeface="Calibri"/>
+              </a:rPr>
+              <a:t>Personal Aspiration: Achieve financial independence to support my family and mentor the next generation.</a:t>
+            </a:r>
+            <a:endParaRPr lang="en-US" sz="2000" b="0" u="none" strike="noStrike">
+              <a:solidFill>
+                <a:srgbClr val="009BDD"/>
+              </a:solidFill>
+              <a:effectLst/>
+              <a:uFillTx/>
+              <a:latin typeface="Times New Roman"/>
+            </a:endParaRPr>
+          </a:p>
+          <a:p>
+            <a:pPr marL="343080" indent="-343080" algn="l" defTabSz="457200">
+              <a:lnSpc>
+                <a:spcPct val="100000"/>
+              </a:lnSpc>
+              <a:spcBef>
+                <a:spcPts val="400"/>
+              </a:spcBef>
+              <a:spcAft>
+                <a:spcPts val="1400"/>
+              </a:spcAft>
+              <a:buClr>
+                <a:srgbClr val="1E293B"/>
+              </a:buClr>
+              <a:buFont typeface="Arial"/>
+              <a:buChar char="•"/>
+            </a:pPr>
+            <a:r>
+              <a:rPr lang="en-US" sz="2000" b="0" u="none" strike="noStrike">
+                <a:solidFill>
+                  <a:srgbClr val="1E293B"/>
+                </a:solidFill>
+                <a:effectLst/>
+                <a:uFillTx/>
+                <a:latin typeface="Calibri"/>
+              </a:rPr>
+              <a:t>Guiding Philosophy: 'Hard work pays' and 'Resilience builds unbreakable strength.'</a:t>
+            </a:r>
+            <a:endParaRPr lang="en-US" sz="2000" b="0" u="none" strike="noStrike">
+              <a:solidFill>
+                <a:srgbClr val="009BDD"/>
               </a:solidFill>
               <a:effectLst/>
               <a:uFillTx/>

</xml_diff>